<commit_message>
gallery: add verified native startup-pitch deck
</commit_message>
<xml_diff>
--- a/gallery/native/startup-pitch/deck.pptx
+++ b/gallery/native/startup-pitch/deck.pptx
@@ -15,11 +15,188 @@
     <p:sldId id="260" r:id="rId7"/>
     <p:sldId id="261" r:id="rId8"/>
     <p:sldId id="262" r:id="rId9"/>
+    <p:sldId id="263" r:id="rId10"/>
+    <p:sldId id="264" r:id="rId11"/>
   </p:sldIdLst>
   <p:sldSz cx="12192000" cy="6858000" type="screen16x9"/>
   <p:notesSz cx="6858000" cy="9144000"/>
   <p:defaultTextStyle/>
 </p:presentation>
+</file>
+
+<file path=ppt/charts/chart1.xml><?xml version="1.0" encoding="utf-8"?>
+<c:chartSpace xmlns:c="http://schemas.openxmlformats.org/drawingml/2006/chart" xmlns:a="http://schemas.openxmlformats.org/drawingml/2006/main" xmlns:r="http://schemas.openxmlformats.org/officeDocument/2006/relationships">
+  <c:lang val="en-US"/>
+  <c:chart>
+    <c:title>
+      <c:tx>
+        <c:rich>
+          <a:bodyPr/>
+          <a:lstStyle/>
+          <a:p>
+            <a:pPr>
+              <a:lnSpc>
+                <a:spcPts val="2196"/>
+              </a:lnSpc>
+              <a:buNone/>
+            </a:pPr>
+            <a:r>
+              <a:rPr lang="en-US" sz="1800" b="0" i="0">
+                <a:solidFill>
+                  <a:srgbClr val="EFF3F5"/>
+                </a:solidFill>
+                <a:latin typeface="Carlito"/>
+              </a:rPr>
+              <a:t xml:space="preserve">Illustrative pilot checkpoints</a:t>
+            </a:r>
+            <a:endParaRPr lang="en-US" sz="1800"/>
+          </a:p>
+        </c:rich>
+      </c:tx>
+    </c:title>
+    <c:plotArea>
+      <c:layout/>
+      <c:barChart>
+        <c:barDir val="col"/>
+        <c:grouping val="clustered"/>
+        <c:varyColors val="0"/>
+        <c:ser>
+          <c:idx val="0"/>
+          <c:order val="0"/>
+          <c:tx>
+            <c:strRef>
+              <c:f>Sheet1!$B$1</c:f>
+              <c:strCache>
+                <c:ptCount val="1"/>
+                <c:pt idx="0">
+                  <c:v>Synthetic score</c:v>
+                </c:pt>
+              </c:strCache>
+            </c:strRef>
+          </c:tx>
+          <c:spPr>
+            <a:solidFill>
+              <a:srgbClr val="9DD8C0"/>
+            </a:solidFill>
+          </c:spPr>
+          <c:cat>
+            <c:strRef>
+              <c:f>Sheet1!$A$2:$A$4</c:f>
+              <c:strCache>
+                <c:ptCount val="3"/>
+                <c:pt idx="0">
+                  <c:v>Baseline</c:v>
+                </c:pt>
+                <c:pt idx="1">
+                  <c:v>Pilot</c:v>
+                </c:pt>
+                <c:pt idx="2">
+                  <c:v>Review</c:v>
+                </c:pt>
+              </c:strCache>
+            </c:strRef>
+          </c:cat>
+          <c:val>
+            <c:numRef>
+              <c:f>Sheet1!$B$2:$B$4</c:f>
+              <c:numCache>
+                <c:formatCode>General</c:formatCode>
+                <c:ptCount val="3"/>
+                <c:pt idx="0">
+                  <c:v>12</c:v>
+                </c:pt>
+                <c:pt idx="1">
+                  <c:v>18</c:v>
+                </c:pt>
+                <c:pt idx="2">
+                  <c:v>24</c:v>
+                </c:pt>
+              </c:numCache>
+            </c:numRef>
+          </c:val>
+        </c:ser>
+        <c:axId val="1"/>
+        <c:axId val="2"/>
+      </c:barChart>
+      <c:catAx>
+        <c:axId val="1"/>
+        <c:scaling>
+          <c:orientation val="minMax"/>
+        </c:scaling>
+        <c:axPos val="b"/>
+        <c:txPr>
+          <a:bodyPr/>
+          <a:lstStyle/>
+          <a:p>
+            <a:pPr>
+              <a:lnSpc>
+                <a:spcPts val="1464"/>
+              </a:lnSpc>
+              <a:buNone/>
+            </a:pPr>
+            <a:r>
+              <a:rPr lang="en-US" sz="1200" b="0" i="0">
+                <a:solidFill>
+                  <a:srgbClr val="EFF3F5"/>
+                </a:solidFill>
+                <a:latin typeface="Carlito"/>
+              </a:rPr>
+              <a:t xml:space="preserve"/>
+            </a:r>
+            <a:endParaRPr lang="en-US" sz="1200"/>
+          </a:p>
+        </c:txPr>
+        <c:crossAx val="2"/>
+        <c:crosses val="autoZero"/>
+      </c:catAx>
+      <c:valAx>
+        <c:axId val="2"/>
+        <c:scaling>
+          <c:orientation val="minMax"/>
+        </c:scaling>
+        <c:axPos val="l"/>
+        <c:numFmt formatCode="General" sourceLinked="0"/>
+        <c:txPr>
+          <a:bodyPr/>
+          <a:lstStyle/>
+          <a:p>
+            <a:pPr>
+              <a:lnSpc>
+                <a:spcPts val="1464"/>
+              </a:lnSpc>
+              <a:buNone/>
+            </a:pPr>
+            <a:r>
+              <a:rPr lang="en-US" sz="1200" b="0" i="0">
+                <a:solidFill>
+                  <a:srgbClr val="EFF3F5"/>
+                </a:solidFill>
+                <a:latin typeface="Carlito"/>
+              </a:rPr>
+              <a:t xml:space="preserve"/>
+            </a:r>
+            <a:endParaRPr lang="en-US" sz="1200"/>
+          </a:p>
+        </c:txPr>
+        <c:crossAx val="1"/>
+        <c:crosses val="autoZero"/>
+        <c:crossBetween val="between"/>
+      </c:valAx>
+    </c:plotArea>
+    <c:legend>
+      <c:legendPos val="b"/>
+    </c:legend>
+    <c:plotVisOnly val="1"/>
+  </c:chart>
+  <c:spPr>
+    <a:solidFill>
+      <a:srgbClr val="141C26"/>
+    </a:solidFill>
+  </c:spPr>
+  <c:externalData r:id="rId1">
+    <c:autoUpdate val="0"/>
+  </c:externalData>
+</c:chartSpace>
 </file>
 
 <file path=ppt/notesMasters/notesMaster1.xml><?xml version="1.0" encoding="utf-8"?>
@@ -89,7 +266,7 @@
                 </a:solidFill>
                 <a:latin typeface="Carlito"/>
               </a:rPr>
-              <a:t xml:space="preserve">Entirely synthetic business example. This deck contains no real customer results, market estimates or fundraising claims.
+              <a:t xml:space="preserve">Synthetic scenario. Figures, roles and organizations are invented to demonstrate the renderer.
 </a:t>
             </a:r>
             <a:endParaRPr lang="en-US" sz="1200"/>
@@ -204,7 +381,7 @@
                 </a:solidFill>
                 <a:latin typeface="Carlito"/>
               </a:rPr>
-              <a:t xml:space="preserve"/>
+              <a:t xml:space="preserve">Synthetic process diagram represented by editable native cards.</a:t>
             </a:r>
             <a:endParaRPr lang="en-US" sz="1200"/>
           </a:p>
@@ -261,7 +438,8 @@
                 </a:solidFill>
                 <a:latin typeface="Carlito"/>
               </a:rPr>
-              <a:t xml:space="preserve"/>
+              <a:t xml:space="preserve">
+Source: Synthetic gallery input · Authored fixture · No real customer, market or investment results are claimed. · author-confirmed: false</a:t>
             </a:r>
             <a:endParaRPr lang="en-US" sz="1200"/>
           </a:p>
@@ -390,6 +568,120 @@
 </file>
 
 <file path=ppt/notesSlides/notesSlide7.xml><?xml version="1.0" encoding="utf-8"?>
+<p:notes xmlns:a="http://schemas.openxmlformats.org/drawingml/2006/main" xmlns:p="http://schemas.openxmlformats.org/presentationml/2006/main" xmlns:r="http://schemas.openxmlformats.org/officeDocument/2006/relationships">
+  <p:cSld>
+    <p:spTree>
+      <p:nvGrpSpPr>
+        <p:cNvPr id="1" name=""/>
+        <p:cNvGrpSpPr/>
+        <p:nvPr/>
+      </p:nvGrpSpPr>
+      <p:grpSpPr>
+        <a:xfrm>
+          <a:off x="0" y="0"/>
+          <a:ext cx="0" cy="0"/>
+          <a:chOff x="0" y="0"/>
+          <a:chExt cx="0" cy="0"/>
+        </a:xfrm>
+      </p:grpSpPr>
+      <p:sp>
+        <p:nvSpPr>
+          <p:cNvPr id="2" name="Speaker notes"/>
+          <p:cNvSpPr/>
+          <p:nvPr>
+            <p:ph type="body" idx="1"/>
+          </p:nvPr>
+        </p:nvSpPr>
+        <p:spPr/>
+        <p:txBody>
+          <a:bodyPr/>
+          <a:lstStyle/>
+          <a:p>
+            <a:pPr>
+              <a:lnSpc>
+                <a:spcPts val="1464"/>
+              </a:lnSpc>
+              <a:buNone/>
+            </a:pPr>
+            <a:r>
+              <a:rPr lang="en-US" sz="1200" b="0" i="0">
+                <a:solidFill>
+                  <a:srgbClr val="EFF3F5"/>
+                </a:solidFill>
+                <a:latin typeface="Carlito"/>
+              </a:rPr>
+              <a:t xml:space="preserve">Synthetic authored principle.</a:t>
+            </a:r>
+            <a:endParaRPr lang="en-US" sz="1200"/>
+          </a:p>
+        </p:txBody>
+      </p:sp>
+    </p:spTree>
+  </p:cSld>
+  <p:clrMapOvr>
+    <a:masterClrMapping/>
+  </p:clrMapOvr>
+</p:notes>
+</file>
+
+<file path=ppt/notesSlides/notesSlide8.xml><?xml version="1.0" encoding="utf-8"?>
+<p:notes xmlns:a="http://schemas.openxmlformats.org/drawingml/2006/main" xmlns:p="http://schemas.openxmlformats.org/presentationml/2006/main" xmlns:r="http://schemas.openxmlformats.org/officeDocument/2006/relationships">
+  <p:cSld>
+    <p:spTree>
+      <p:nvGrpSpPr>
+        <p:cNvPr id="1" name=""/>
+        <p:cNvGrpSpPr/>
+        <p:nvPr/>
+      </p:nvGrpSpPr>
+      <p:grpSpPr>
+        <a:xfrm>
+          <a:off x="0" y="0"/>
+          <a:ext cx="0" cy="0"/>
+          <a:chOff x="0" y="0"/>
+          <a:chExt cx="0" cy="0"/>
+        </a:xfrm>
+      </p:grpSpPr>
+      <p:sp>
+        <p:nvSpPr>
+          <p:cNvPr id="2" name="Speaker notes"/>
+          <p:cNvSpPr/>
+          <p:nvPr>
+            <p:ph type="body" idx="1"/>
+          </p:nvPr>
+        </p:nvSpPr>
+        <p:spPr/>
+        <p:txBody>
+          <a:bodyPr/>
+          <a:lstStyle/>
+          <a:p>
+            <a:pPr>
+              <a:lnSpc>
+                <a:spcPts val="1464"/>
+              </a:lnSpc>
+              <a:buNone/>
+            </a:pPr>
+            <a:r>
+              <a:rPr lang="en-US" sz="1200" b="0" i="0">
+                <a:solidFill>
+                  <a:srgbClr val="EFF3F5"/>
+                </a:solidFill>
+                <a:latin typeface="Carlito"/>
+              </a:rPr>
+              <a:t xml:space="preserve"/>
+            </a:r>
+            <a:endParaRPr lang="en-US" sz="1200"/>
+          </a:p>
+        </p:txBody>
+      </p:sp>
+    </p:spTree>
+  </p:cSld>
+  <p:clrMapOvr>
+    <a:masterClrMapping/>
+  </p:clrMapOvr>
+</p:notes>
+</file>
+
+<file path=ppt/notesSlides/notesSlide9.xml><?xml version="1.0" encoding="utf-8"?>
 <p:notes xmlns:a="http://schemas.openxmlformats.org/drawingml/2006/main" xmlns:p="http://schemas.openxmlformats.org/presentationml/2006/main" xmlns:r="http://schemas.openxmlformats.org/officeDocument/2006/relationships">
   <p:cSld>
     <p:spTree>
@@ -504,7 +796,7 @@
 
 <file path=ppt/slides/slide1.xml><?xml version="1.0" encoding="utf-8"?>
 <p:sld xmlns:a="http://schemas.openxmlformats.org/drawingml/2006/main" xmlns:p="http://schemas.openxmlformats.org/presentationml/2006/main" xmlns:r="http://schemas.openxmlformats.org/officeDocument/2006/relationships">
-  <p:cSld name="Research teams lose the thread between interviews">
+  <p:cSld name="The context for research handoffs">
     <p:bg>
       <p:bgPr>
         <a:solidFill>
@@ -609,7 +901,7 @@
                 </a:solidFill>
                 <a:latin typeface="Carlito"/>
               </a:rPr>
-              <a:t xml:space="preserve">Research teams lose the thread between interviews</a:t>
+              <a:t xml:space="preserve">The context for research handoffs</a:t>
             </a:r>
             <a:endParaRPr lang="en-US" sz="4000"/>
           </a:p>
@@ -653,7 +945,7 @@
                 </a:solidFill>
                 <a:latin typeface="Carlito"/>
               </a:rPr>
-              <a:t xml:space="preserve">A fictional product team stores interview notes in documents, decisions in chat, and research </a:t>
+              <a:t xml:space="preserve">This fictional team needs a decision it can explain, execute, and revisit. Documents lose the </a:t>
             </a:r>
             <a:endParaRPr lang="en-US" sz="2200"/>
           </a:p>
@@ -671,7 +963,7 @@
                 </a:solidFill>
                 <a:latin typeface="Carlito"/>
               </a:rPr>
-              <a:t xml:space="preserve">plans in spreadsheets. Insights become difficult to trace when the project changes hands.</a:t>
+              <a:t xml:space="preserve">connection between excerpts and decisions.</a:t>
             </a:r>
             <a:endParaRPr lang="en-US" sz="2200"/>
           </a:p>
@@ -798,7 +1090,7 @@
 
 <file path=ppt/slides/slide2.xml><?xml version="1.0" encoding="utf-8"?>
 <p:sld xmlns:a="http://schemas.openxmlformats.org/drawingml/2006/main" xmlns:p="http://schemas.openxmlformats.org/presentationml/2006/main" xmlns:r="http://schemas.openxmlformats.org/officeDocument/2006/relationships">
-  <p:cSld name="The problem is continuity, not another note-taking tool">
+  <p:cSld name="The problem is the missing decision boundary">
     <p:bg>
       <p:bgPr>
         <a:solidFill>
@@ -859,7 +1151,7 @@
                 </a:solidFill>
                 <a:latin typeface="Carlito"/>
               </a:rPr>
-              <a:t xml:space="preserve">FIELDWORK — THE RESEARCH WORKSPACE  /  PROBLEM</a:t>
+              <a:t xml:space="preserve">FIELDWORK — THE RESEARCH WORKSPACE  /  RECOMMENDATION</a:t>
             </a:r>
             <a:endParaRPr lang="en-US" sz="1100"/>
           </a:p>
@@ -903,417 +1195,59 @@
                 </a:solidFill>
                 <a:latin typeface="Carlito"/>
               </a:rPr>
-              <a:t xml:space="preserve">The problem is continuity, not another note-taking </a:t>
+              <a:t xml:space="preserve">The problem is the missing decision boundary</a:t>
             </a:r>
             <a:endParaRPr lang="en-US" sz="4000"/>
           </a:p>
-          <a:p>
-            <a:pPr>
-              <a:lnSpc>
-                <a:spcPts val="4880"/>
-              </a:lnSpc>
-              <a:buNone/>
-            </a:pPr>
-            <a:r>
-              <a:rPr lang="en-US" sz="4000" b="1" i="0">
-                <a:solidFill>
-                  <a:srgbClr val="EFF3F5"/>
-                </a:solidFill>
-                <a:latin typeface="Carlito"/>
-              </a:rPr>
-              <a:t xml:space="preserve">tool</a:t>
-            </a:r>
-            <a:endParaRPr lang="en-US" sz="4000"/>
-          </a:p>
-        </p:txBody>
-      </p:sp>
-      <p:sp>
-        <p:nvSpPr>
-          <p:cNvPr id="4" name="Shape 4"/>
-          <p:cNvSpPr/>
+        </p:txBody>
+      </p:sp>
+      <p:sp>
+        <p:nvSpPr>
+          <p:cNvPr id="4" name="Text 4"/>
+          <p:cNvSpPr txBox="1"/>
           <p:nvPr/>
         </p:nvSpPr>
         <p:spPr>
           <a:xfrm>
             <a:off x="609600" y="2336800"/>
-            <a:ext cx="5372100" cy="1663700"/>
-          </a:xfrm>
-          <a:prstGeom prst="roundRect">
-            <a:avLst/>
-          </a:prstGeom>
-          <a:solidFill>
-            <a:srgbClr val="202D3C"/>
-          </a:solidFill>
-          <a:ln>
-            <a:noFill/>
-          </a:ln>
-        </p:spPr>
-      </p:sp>
-      <p:sp>
-        <p:nvSpPr>
-          <p:cNvPr id="5" name="Text 5"/>
-          <p:cNvSpPr txBox="1"/>
-          <p:nvPr/>
-        </p:nvSpPr>
-        <p:spPr>
-          <a:xfrm>
-            <a:off x="812800" y="2540000"/>
-            <a:ext cx="4965700" cy="528066"/>
-          </a:xfrm>
-          <a:prstGeom prst="rect">
-            <a:avLst/>
-          </a:prstGeom>
-          <a:noFill/>
-          <a:ln>
-            <a:noFill/>
-          </a:ln>
-        </p:spPr>
-        <p:txBody>
-          <a:bodyPr wrap="none" lIns="0" tIns="0" rIns="0" bIns="0" anchor="t">
-            <a:noAutofit/>
-          </a:bodyPr>
-          <a:lstStyle/>
-          <a:p>
-            <a:pPr>
-              <a:lnSpc>
-                <a:spcPts val="2928"/>
-              </a:lnSpc>
-              <a:buNone/>
-            </a:pPr>
-            <a:r>
-              <a:rPr lang="en-US" sz="2400" b="1" i="0">
-                <a:solidFill>
-                  <a:srgbClr val="EFF3F5"/>
-                </a:solidFill>
-                <a:latin typeface="Carlito"/>
-              </a:rPr>
-              <a:t xml:space="preserve">Fragmented evidence</a:t>
-            </a:r>
-            <a:endParaRPr lang="en-US" sz="2400"/>
-          </a:p>
-        </p:txBody>
-      </p:sp>
-      <p:sp>
-        <p:nvSpPr>
-          <p:cNvPr id="6" name="Text 6"/>
-          <p:cNvSpPr txBox="1"/>
-          <p:nvPr/>
-        </p:nvSpPr>
-        <p:spPr>
-          <a:xfrm>
-            <a:off x="812800" y="3169666"/>
-            <a:ext cx="4965700" cy="627634"/>
-          </a:xfrm>
-          <a:prstGeom prst="rect">
-            <a:avLst/>
-          </a:prstGeom>
-          <a:noFill/>
-          <a:ln>
-            <a:noFill/>
-          </a:ln>
-        </p:spPr>
-        <p:txBody>
-          <a:bodyPr wrap="none" lIns="0" tIns="0" rIns="0" bIns="0" anchor="t">
-            <a:noAutofit/>
-          </a:bodyPr>
-          <a:lstStyle/>
-          <a:p>
-            <a:pPr>
-              <a:lnSpc>
-                <a:spcPts val="2440"/>
-              </a:lnSpc>
-              <a:buNone/>
-            </a:pPr>
-            <a:r>
-              <a:rPr lang="en-US" sz="2000" b="0" i="0">
-                <a:solidFill>
-                  <a:srgbClr val="EFF3F5"/>
-                </a:solidFill>
-                <a:latin typeface="Carlito"/>
-              </a:rPr>
-              <a:t xml:space="preserve">An insight has no durable link to the interview </a:t>
-            </a:r>
-            <a:endParaRPr lang="en-US" sz="2000"/>
-          </a:p>
-          <a:p>
-            <a:pPr>
-              <a:lnSpc>
-                <a:spcPts val="2440"/>
-              </a:lnSpc>
-              <a:buNone/>
-            </a:pPr>
-            <a:r>
-              <a:rPr lang="en-US" sz="2000" b="0" i="0">
-                <a:solidFill>
-                  <a:srgbClr val="EFF3F5"/>
-                </a:solidFill>
-                <a:latin typeface="Carlito"/>
-              </a:rPr>
-              <a:t xml:space="preserve">excerpt that supports it.</a:t>
-            </a:r>
-            <a:endParaRPr lang="en-US" sz="2000"/>
-          </a:p>
-        </p:txBody>
-      </p:sp>
-      <p:sp>
-        <p:nvSpPr>
-          <p:cNvPr id="7" name="Shape 7"/>
-          <p:cNvSpPr/>
-          <p:nvPr/>
-        </p:nvSpPr>
-        <p:spPr>
-          <a:xfrm>
-            <a:off x="6210300" y="2336800"/>
-            <a:ext cx="5372100" cy="1663700"/>
-          </a:xfrm>
-          <a:prstGeom prst="roundRect">
-            <a:avLst/>
-          </a:prstGeom>
-          <a:solidFill>
-            <a:srgbClr val="202D3C"/>
-          </a:solidFill>
-          <a:ln>
-            <a:noFill/>
-          </a:ln>
-        </p:spPr>
-      </p:sp>
-      <p:sp>
-        <p:nvSpPr>
-          <p:cNvPr id="8" name="Text 8"/>
-          <p:cNvSpPr txBox="1"/>
-          <p:nvPr/>
-        </p:nvSpPr>
-        <p:spPr>
-          <a:xfrm>
-            <a:off x="6413500" y="2540000"/>
-            <a:ext cx="4965700" cy="528066"/>
-          </a:xfrm>
-          <a:prstGeom prst="rect">
-            <a:avLst/>
-          </a:prstGeom>
-          <a:noFill/>
-          <a:ln>
-            <a:noFill/>
-          </a:ln>
-        </p:spPr>
-        <p:txBody>
-          <a:bodyPr wrap="none" lIns="0" tIns="0" rIns="0" bIns="0" anchor="t">
-            <a:noAutofit/>
-          </a:bodyPr>
-          <a:lstStyle/>
-          <a:p>
-            <a:pPr>
-              <a:lnSpc>
-                <a:spcPts val="2928"/>
-              </a:lnSpc>
-              <a:buNone/>
-            </a:pPr>
-            <a:r>
-              <a:rPr lang="en-US" sz="2400" b="1" i="0">
-                <a:solidFill>
-                  <a:srgbClr val="EFF3F5"/>
-                </a:solidFill>
-                <a:latin typeface="Carlito"/>
-              </a:rPr>
-              <a:t xml:space="preserve">Unclear decisions</a:t>
-            </a:r>
-            <a:endParaRPr lang="en-US" sz="2400"/>
-          </a:p>
-        </p:txBody>
-      </p:sp>
-      <p:sp>
-        <p:nvSpPr>
-          <p:cNvPr id="9" name="Text 9"/>
-          <p:cNvSpPr txBox="1"/>
-          <p:nvPr/>
-        </p:nvSpPr>
-        <p:spPr>
-          <a:xfrm>
-            <a:off x="6413500" y="3169666"/>
-            <a:ext cx="4965700" cy="627634"/>
-          </a:xfrm>
-          <a:prstGeom prst="rect">
-            <a:avLst/>
-          </a:prstGeom>
-          <a:noFill/>
-          <a:ln>
-            <a:noFill/>
-          </a:ln>
-        </p:spPr>
-        <p:txBody>
-          <a:bodyPr wrap="none" lIns="0" tIns="0" rIns="0" bIns="0" anchor="t">
-            <a:noAutofit/>
-          </a:bodyPr>
-          <a:lstStyle/>
-          <a:p>
-            <a:pPr>
-              <a:lnSpc>
-                <a:spcPts val="2440"/>
-              </a:lnSpc>
-              <a:buNone/>
-            </a:pPr>
-            <a:r>
-              <a:rPr lang="en-US" sz="2000" b="0" i="0">
-                <a:solidFill>
-                  <a:srgbClr val="EFF3F5"/>
-                </a:solidFill>
-                <a:latin typeface="Carlito"/>
-              </a:rPr>
-              <a:t xml:space="preserve">The team cannot easily tell which open </a:t>
-            </a:r>
-            <a:endParaRPr lang="en-US" sz="2000"/>
-          </a:p>
-          <a:p>
-            <a:pPr>
-              <a:lnSpc>
-                <a:spcPts val="2440"/>
-              </a:lnSpc>
-              <a:buNone/>
-            </a:pPr>
-            <a:r>
-              <a:rPr lang="en-US" sz="2000" b="0" i="0">
-                <a:solidFill>
-                  <a:srgbClr val="EFF3F5"/>
-                </a:solidFill>
-                <a:latin typeface="Carlito"/>
-              </a:rPr>
-              <a:t xml:space="preserve">questions changed the product direction.</a:t>
-            </a:r>
-            <a:endParaRPr lang="en-US" sz="2000"/>
-          </a:p>
-        </p:txBody>
-      </p:sp>
-      <p:sp>
-        <p:nvSpPr>
-          <p:cNvPr id="10" name="Shape 10"/>
-          <p:cNvSpPr/>
-          <p:nvPr/>
-        </p:nvSpPr>
-        <p:spPr>
-          <a:xfrm>
-            <a:off x="609600" y="4229100"/>
-            <a:ext cx="5372100" cy="1663700"/>
-          </a:xfrm>
-          <a:prstGeom prst="roundRect">
-            <a:avLst/>
-          </a:prstGeom>
-          <a:solidFill>
-            <a:srgbClr val="202D3C"/>
-          </a:solidFill>
-          <a:ln>
-            <a:noFill/>
-          </a:ln>
-        </p:spPr>
-      </p:sp>
-      <p:sp>
-        <p:nvSpPr>
-          <p:cNvPr id="11" name="Text 11"/>
-          <p:cNvSpPr txBox="1"/>
-          <p:nvPr/>
-        </p:nvSpPr>
-        <p:spPr>
-          <a:xfrm>
-            <a:off x="812800" y="4432300"/>
-            <a:ext cx="4965700" cy="528066"/>
-          </a:xfrm>
-          <a:prstGeom prst="rect">
-            <a:avLst/>
-          </a:prstGeom>
-          <a:noFill/>
-          <a:ln>
-            <a:noFill/>
-          </a:ln>
-        </p:spPr>
-        <p:txBody>
-          <a:bodyPr wrap="none" lIns="0" tIns="0" rIns="0" bIns="0" anchor="t">
-            <a:noAutofit/>
-          </a:bodyPr>
-          <a:lstStyle/>
-          <a:p>
-            <a:pPr>
-              <a:lnSpc>
-                <a:spcPts val="2928"/>
-              </a:lnSpc>
-              <a:buNone/>
-            </a:pPr>
-            <a:r>
-              <a:rPr lang="en-US" sz="2400" b="1" i="0">
-                <a:solidFill>
-                  <a:srgbClr val="EFF3F5"/>
-                </a:solidFill>
-                <a:latin typeface="Carlito"/>
-              </a:rPr>
-              <a:t xml:space="preserve">Expensive handoffs</a:t>
-            </a:r>
-            <a:endParaRPr lang="en-US" sz="2400"/>
-          </a:p>
-        </p:txBody>
-      </p:sp>
-      <p:sp>
-        <p:nvSpPr>
-          <p:cNvPr id="12" name="Text 12"/>
-          <p:cNvSpPr txBox="1"/>
-          <p:nvPr/>
-        </p:nvSpPr>
-        <p:spPr>
-          <a:xfrm>
-            <a:off x="812800" y="5061966"/>
-            <a:ext cx="4965700" cy="627634"/>
-          </a:xfrm>
-          <a:prstGeom prst="rect">
-            <a:avLst/>
-          </a:prstGeom>
-          <a:noFill/>
-          <a:ln>
-            <a:noFill/>
-          </a:ln>
-        </p:spPr>
-        <p:txBody>
-          <a:bodyPr wrap="none" lIns="0" tIns="0" rIns="0" bIns="0" anchor="t">
-            <a:noAutofit/>
-          </a:bodyPr>
-          <a:lstStyle/>
-          <a:p>
-            <a:pPr>
-              <a:lnSpc>
-                <a:spcPts val="2440"/>
-              </a:lnSpc>
-              <a:buNone/>
-            </a:pPr>
-            <a:r>
-              <a:rPr lang="en-US" sz="2000" b="0" i="0">
-                <a:solidFill>
-                  <a:srgbClr val="EFF3F5"/>
-                </a:solidFill>
-                <a:latin typeface="Carlito"/>
-              </a:rPr>
-              <a:t xml:space="preserve">The next researcher starts by reconstructing </a:t>
-            </a:r>
-            <a:endParaRPr lang="en-US" sz="2000"/>
-          </a:p>
-          <a:p>
-            <a:pPr>
-              <a:lnSpc>
-                <a:spcPts val="2440"/>
-              </a:lnSpc>
-              <a:buNone/>
-            </a:pPr>
-            <a:r>
-              <a:rPr lang="en-US" sz="2000" b="0" i="0">
-                <a:solidFill>
-                  <a:srgbClr val="EFF3F5"/>
-                </a:solidFill>
-                <a:latin typeface="Carlito"/>
-              </a:rPr>
-              <a:t xml:space="preserve">the previous project.</a:t>
-            </a:r>
-            <a:endParaRPr lang="en-US" sz="2000"/>
-          </a:p>
-        </p:txBody>
-      </p:sp>
-      <p:sp>
-        <p:nvSpPr>
-          <p:cNvPr id="13" name="Shape 13"/>
+            <a:ext cx="10972800" cy="3556000"/>
+          </a:xfrm>
+          <a:prstGeom prst="rect">
+            <a:avLst/>
+          </a:prstGeom>
+          <a:noFill/>
+          <a:ln>
+            <a:noFill/>
+          </a:ln>
+        </p:spPr>
+        <p:txBody>
+          <a:bodyPr wrap="none" lIns="0" tIns="0" rIns="0" bIns="0" anchor="t">
+            <a:noAutofit/>
+          </a:bodyPr>
+          <a:lstStyle/>
+          <a:p>
+            <a:pPr>
+              <a:lnSpc>
+                <a:spcPts val="2684"/>
+              </a:lnSpc>
+              <a:buNone/>
+            </a:pPr>
+            <a:r>
+              <a:rPr lang="en-US" sz="2200" b="0" i="0">
+                <a:solidFill>
+                  <a:srgbClr val="EFF3F5"/>
+                </a:solidFill>
+                <a:latin typeface="Carlito"/>
+              </a:rPr>
+              <a:t xml:space="preserve">Documents lose the connection between excerpts and decisions.</a:t>
+            </a:r>
+            <a:endParaRPr lang="en-US" sz="2200"/>
+          </a:p>
+        </p:txBody>
+      </p:sp>
+      <p:sp>
+        <p:nvSpPr>
+          <p:cNvPr id="5" name="Shape 5"/>
           <p:cNvSpPr/>
           <p:nvPr/>
         </p:nvSpPr>
@@ -1336,7 +1270,7 @@
       </p:sp>
       <p:sp>
         <p:nvSpPr>
-          <p:cNvPr id="14" name="Text 14"/>
+          <p:cNvPr id="6" name="Text 6"/>
           <p:cNvSpPr txBox="1"/>
           <p:nvPr/>
         </p:nvSpPr>
@@ -1380,7 +1314,7 @@
       </p:sp>
       <p:sp>
         <p:nvSpPr>
-          <p:cNvPr id="15" name="Text 15"/>
+          <p:cNvPr id="7" name="Text 7"/>
           <p:cNvSpPr txBox="1"/>
           <p:nvPr/>
         </p:nvSpPr>
@@ -1432,7 +1366,7 @@
 
 <file path=ppt/slides/slide3.xml><?xml version="1.0" encoding="utf-8"?>
 <p:sld xmlns:a="http://schemas.openxmlformats.org/drawingml/2006/main" xmlns:p="http://schemas.openxmlformats.org/presentationml/2006/main" xmlns:r="http://schemas.openxmlformats.org/officeDocument/2006/relationships">
-  <p:cSld name="Evidence to gather before expanding the pilot">
+  <p:cSld name="A smaller boundary makes the work reviewable">
     <p:bg>
       <p:bgPr>
         <a:solidFill>
@@ -1493,7 +1427,7 @@
                 </a:solidFill>
                 <a:latin typeface="Carlito"/>
               </a:rPr>
-              <a:t xml:space="preserve">FIELDWORK — THE RESEARCH WORKSPACE  /  EVIDENCE</a:t>
+              <a:t xml:space="preserve">FIELDWORK — THE RESEARCH WORKSPACE  /  PROBLEM</a:t>
             </a:r>
             <a:endParaRPr lang="en-US" sz="1100"/>
           </a:p>
@@ -1537,7 +1471,7 @@
                 </a:solidFill>
                 <a:latin typeface="Carlito"/>
               </a:rPr>
-              <a:t xml:space="preserve">Evidence to gather before expanding the pilot</a:t>
+              <a:t xml:space="preserve">A smaller boundary makes the work reviewable</a:t>
             </a:r>
             <a:endParaRPr lang="en-US" sz="4000"/>
           </a:p>
@@ -1552,7 +1486,7 @@
         <p:spPr>
           <a:xfrm>
             <a:off x="609600" y="2336800"/>
-            <a:ext cx="5372100" cy="3556000"/>
+            <a:ext cx="3505200" cy="3556000"/>
           </a:xfrm>
           <a:prstGeom prst="roundRect">
             <a:avLst/>
@@ -1574,7 +1508,7 @@
         <p:spPr>
           <a:xfrm>
             <a:off x="812800" y="2540000"/>
-            <a:ext cx="4965700" cy="812800"/>
+            <a:ext cx="3098800" cy="812800"/>
           </a:xfrm>
           <a:prstGeom prst="rect">
             <a:avLst/>
@@ -1603,7 +1537,7 @@
                 </a:solidFill>
                 <a:latin typeface="Carlito"/>
               </a:rPr>
-              <a:t xml:space="preserve">Interview researchers</a:t>
+              <a:t xml:space="preserve">Observe</a:t>
             </a:r>
             <a:endParaRPr lang="en-US" sz="2400"/>
           </a:p>
@@ -1618,7 +1552,7 @@
         <p:spPr>
           <a:xfrm>
             <a:off x="812800" y="3454400"/>
-            <a:ext cx="4965700" cy="2235200"/>
+            <a:ext cx="3098800" cy="2235200"/>
           </a:xfrm>
           <a:prstGeom prst="rect">
             <a:avLst/>
@@ -1647,61 +1581,7 @@
                 </a:solidFill>
                 <a:latin typeface="Carlito"/>
               </a:rPr>
-              <a:t xml:space="preserve">Observe how participants locate an </a:t>
-            </a:r>
-            <a:endParaRPr lang="en-US" sz="2200"/>
-          </a:p>
-          <a:p>
-            <a:pPr>
-              <a:lnSpc>
-                <a:spcPts val="2684"/>
-              </a:lnSpc>
-              <a:buNone/>
-            </a:pPr>
-            <a:r>
-              <a:rPr lang="en-US" sz="2200" b="0" i="0">
-                <a:solidFill>
-                  <a:srgbClr val="EFF3F5"/>
-                </a:solidFill>
-                <a:latin typeface="Carlito"/>
-              </a:rPr>
-              <a:t xml:space="preserve">excerpt and reconstruct a decision. Treat </a:t>
-            </a:r>
-            <a:endParaRPr lang="en-US" sz="2200"/>
-          </a:p>
-          <a:p>
-            <a:pPr>
-              <a:lnSpc>
-                <a:spcPts val="2684"/>
-              </a:lnSpc>
-              <a:buNone/>
-            </a:pPr>
-            <a:r>
-              <a:rPr lang="en-US" sz="2200" b="0" i="0">
-                <a:solidFill>
-                  <a:srgbClr val="EFF3F5"/>
-                </a:solidFill>
-                <a:latin typeface="Carlito"/>
-              </a:rPr>
-              <a:t xml:space="preserve">findings as unresolved until the author </a:t>
-            </a:r>
-            <a:endParaRPr lang="en-US" sz="2200"/>
-          </a:p>
-          <a:p>
-            <a:pPr>
-              <a:lnSpc>
-                <a:spcPts val="2684"/>
-              </a:lnSpc>
-              <a:buNone/>
-            </a:pPr>
-            <a:r>
-              <a:rPr lang="en-US" sz="2200" b="0" i="0">
-                <a:solidFill>
-                  <a:srgbClr val="EFF3F5"/>
-                </a:solidFill>
-                <a:latin typeface="Carlito"/>
-              </a:rPr>
-              <a:t xml:space="preserve">reviews them.</a:t>
+              <a:t xml:space="preserve">Start with one actual task.</a:t>
             </a:r>
             <a:endParaRPr lang="en-US" sz="2200"/>
           </a:p>
@@ -1715,8 +1595,8 @@
         </p:nvSpPr>
         <p:spPr>
           <a:xfrm>
-            <a:off x="6210300" y="2336800"/>
-            <a:ext cx="5372100" cy="3556000"/>
+            <a:off x="4343400" y="2336800"/>
+            <a:ext cx="3505200" cy="3556000"/>
           </a:xfrm>
           <a:prstGeom prst="roundRect">
             <a:avLst/>
@@ -1737,8 +1617,8 @@
         </p:nvSpPr>
         <p:spPr>
           <a:xfrm>
-            <a:off x="6413500" y="2540000"/>
-            <a:ext cx="4965700" cy="812800"/>
+            <a:off x="4546600" y="2540000"/>
+            <a:ext cx="3098800" cy="812800"/>
           </a:xfrm>
           <a:prstGeom prst="rect">
             <a:avLst/>
@@ -1767,7 +1647,7 @@
                 </a:solidFill>
                 <a:latin typeface="Carlito"/>
               </a:rPr>
-              <a:t xml:space="preserve">Test the handoff</a:t>
+              <a:t xml:space="preserve">Decide</a:t>
             </a:r>
             <a:endParaRPr lang="en-US" sz="2400"/>
           </a:p>
@@ -1781,8 +1661,8 @@
         </p:nvSpPr>
         <p:spPr>
           <a:xfrm>
-            <a:off x="6413500" y="3454400"/>
-            <a:ext cx="4965700" cy="2235200"/>
+            <a:off x="4546600" y="3454400"/>
+            <a:ext cx="3098800" cy="2235200"/>
           </a:xfrm>
           <a:prstGeom prst="rect">
             <a:avLst/>
@@ -1811,7 +1691,7 @@
                 </a:solidFill>
                 <a:latin typeface="Carlito"/>
               </a:rPr>
-              <a:t xml:space="preserve">Ask a second researcher to continue a </a:t>
+              <a:t xml:space="preserve">Name the trade-off and </a:t>
             </a:r>
             <a:endParaRPr lang="en-US" sz="2200"/>
           </a:p>
@@ -1829,7 +1709,7 @@
                 </a:solidFill>
                 <a:latin typeface="Carlito"/>
               </a:rPr>
-              <a:t xml:space="preserve">synthetic project without a verbal briefing.</a:t>
+              <a:t xml:space="preserve">owner.</a:t>
             </a:r>
             <a:endParaRPr lang="en-US" sz="2200"/>
           </a:p>
@@ -1838,6 +1718,134 @@
       <p:sp>
         <p:nvSpPr>
           <p:cNvPr id="10" name="Shape 10"/>
+          <p:cNvSpPr/>
+          <p:nvPr/>
+        </p:nvSpPr>
+        <p:spPr>
+          <a:xfrm>
+            <a:off x="8077200" y="2336800"/>
+            <a:ext cx="3505200" cy="3556000"/>
+          </a:xfrm>
+          <a:prstGeom prst="roundRect">
+            <a:avLst/>
+          </a:prstGeom>
+          <a:solidFill>
+            <a:srgbClr val="202D3C"/>
+          </a:solidFill>
+          <a:ln>
+            <a:noFill/>
+          </a:ln>
+        </p:spPr>
+      </p:sp>
+      <p:sp>
+        <p:nvSpPr>
+          <p:cNvPr id="11" name="Text 11"/>
+          <p:cNvSpPr txBox="1"/>
+          <p:nvPr/>
+        </p:nvSpPr>
+        <p:spPr>
+          <a:xfrm>
+            <a:off x="8280400" y="2540000"/>
+            <a:ext cx="3098800" cy="812800"/>
+          </a:xfrm>
+          <a:prstGeom prst="rect">
+            <a:avLst/>
+          </a:prstGeom>
+          <a:noFill/>
+          <a:ln>
+            <a:noFill/>
+          </a:ln>
+        </p:spPr>
+        <p:txBody>
+          <a:bodyPr wrap="none" lIns="0" tIns="0" rIns="0" bIns="0" anchor="t">
+            <a:noAutofit/>
+          </a:bodyPr>
+          <a:lstStyle/>
+          <a:p>
+            <a:pPr>
+              <a:lnSpc>
+                <a:spcPts val="2928"/>
+              </a:lnSpc>
+              <a:buNone/>
+            </a:pPr>
+            <a:r>
+              <a:rPr lang="en-US" sz="2400" b="1" i="0">
+                <a:solidFill>
+                  <a:srgbClr val="EFF3F5"/>
+                </a:solidFill>
+                <a:latin typeface="Carlito"/>
+              </a:rPr>
+              <a:t xml:space="preserve">Review</a:t>
+            </a:r>
+            <a:endParaRPr lang="en-US" sz="2400"/>
+          </a:p>
+        </p:txBody>
+      </p:sp>
+      <p:sp>
+        <p:nvSpPr>
+          <p:cNvPr id="12" name="Text 12"/>
+          <p:cNvSpPr txBox="1"/>
+          <p:nvPr/>
+        </p:nvSpPr>
+        <p:spPr>
+          <a:xfrm>
+            <a:off x="8280400" y="3454400"/>
+            <a:ext cx="3098800" cy="2235200"/>
+          </a:xfrm>
+          <a:prstGeom prst="rect">
+            <a:avLst/>
+          </a:prstGeom>
+          <a:noFill/>
+          <a:ln>
+            <a:noFill/>
+          </a:ln>
+        </p:spPr>
+        <p:txBody>
+          <a:bodyPr wrap="none" lIns="0" tIns="0" rIns="0" bIns="0" anchor="t">
+            <a:noAutofit/>
+          </a:bodyPr>
+          <a:lstStyle/>
+          <a:p>
+            <a:pPr>
+              <a:lnSpc>
+                <a:spcPts val="2684"/>
+              </a:lnSpc>
+              <a:buNone/>
+            </a:pPr>
+            <a:r>
+              <a:rPr lang="en-US" sz="2200" b="0" i="0">
+                <a:solidFill>
+                  <a:srgbClr val="EFF3F5"/>
+                </a:solidFill>
+                <a:latin typeface="Carlito"/>
+              </a:rPr>
+              <a:t xml:space="preserve">Inspect the outcome </a:t>
+            </a:r>
+            <a:endParaRPr lang="en-US" sz="2200"/>
+          </a:p>
+          <a:p>
+            <a:pPr>
+              <a:lnSpc>
+                <a:spcPts val="2684"/>
+              </a:lnSpc>
+              <a:buNone/>
+            </a:pPr>
+            <a:r>
+              <a:rPr lang="en-US" sz="2200" b="0" i="0">
+                <a:solidFill>
+                  <a:srgbClr val="EFF3F5"/>
+                </a:solidFill>
+                <a:latin typeface="Carlito"/>
+              </a:rPr>
+              <a:t xml:space="preserve">before expanding.</a:t>
+            </a:r>
+            <a:endParaRPr lang="en-US" sz="2200"/>
+          </a:p>
+        </p:txBody>
+      </p:sp>
+      <p:sp>
+        <p:nvSpPr>
+          <p:cNvPr id="13" name="Shape 13"/>
           <p:cNvSpPr/>
           <p:nvPr/>
         </p:nvSpPr>
@@ -1860,7 +1868,7 @@
       </p:sp>
       <p:sp>
         <p:nvSpPr>
-          <p:cNvPr id="11" name="Text 11"/>
+          <p:cNvPr id="14" name="Text 14"/>
           <p:cNvSpPr txBox="1"/>
           <p:nvPr/>
         </p:nvSpPr>
@@ -1904,7 +1912,7 @@
       </p:sp>
       <p:sp>
         <p:nvSpPr>
-          <p:cNvPr id="12" name="Text 12"/>
+          <p:cNvPr id="15" name="Text 15"/>
           <p:cNvSpPr txBox="1"/>
           <p:nvPr/>
         </p:nvSpPr>
@@ -1956,7 +1964,7 @@
 
 <file path=ppt/slides/slide4.xml><?xml version="1.0" encoding="utf-8"?>
 <p:sld xmlns:a="http://schemas.openxmlformats.org/drawingml/2006/main" xmlns:p="http://schemas.openxmlformats.org/presentationml/2006/main" xmlns:r="http://schemas.openxmlformats.org/officeDocument/2006/relationships">
-  <p:cSld name="Two options trade speed against traceability">
+  <p:cSld name="Evidence to gather before committing">
     <p:bg>
       <p:bgPr>
         <a:solidFill>
@@ -2017,7 +2025,7 @@
                 </a:solidFill>
                 <a:latin typeface="Carlito"/>
               </a:rPr>
-              <a:t xml:space="preserve">FIELDWORK — THE RESEARCH WORKSPACE  /  OPTIONS</a:t>
+              <a:t xml:space="preserve">FIELDWORK — THE RESEARCH WORKSPACE  /  EVIDENCE</a:t>
             </a:r>
             <a:endParaRPr lang="en-US" sz="1100"/>
           </a:p>
@@ -2061,307 +2069,31 @@
                 </a:solidFill>
                 <a:latin typeface="Carlito"/>
               </a:rPr>
-              <a:t xml:space="preserve">Two options trade speed against traceability</a:t>
+              <a:t xml:space="preserve">Evidence to gather before committing</a:t>
             </a:r>
             <a:endParaRPr lang="en-US" sz="4000"/>
           </a:p>
         </p:txBody>
       </p:sp>
-      <p:sp>
-        <p:nvSpPr>
-          <p:cNvPr id="4" name="Shape 4"/>
-          <p:cNvSpPr/>
-          <p:nvPr/>
-        </p:nvSpPr>
-        <p:spPr>
-          <a:xfrm>
-            <a:off x="609600" y="2336800"/>
-            <a:ext cx="5372100" cy="3556000"/>
-          </a:xfrm>
-          <a:prstGeom prst="roundRect">
-            <a:avLst/>
-          </a:prstGeom>
-          <a:solidFill>
-            <a:srgbClr val="202D3C"/>
-          </a:solidFill>
-          <a:ln>
-            <a:noFill/>
-          </a:ln>
-        </p:spPr>
-      </p:sp>
-      <p:sp>
-        <p:nvSpPr>
-          <p:cNvPr id="5" name="Text 5"/>
-          <p:cNvSpPr txBox="1"/>
-          <p:nvPr/>
-        </p:nvSpPr>
-        <p:spPr>
-          <a:xfrm>
-            <a:off x="812800" y="2540000"/>
-            <a:ext cx="4965700" cy="812800"/>
-          </a:xfrm>
-          <a:prstGeom prst="rect">
-            <a:avLst/>
-          </a:prstGeom>
-          <a:noFill/>
-          <a:ln>
-            <a:noFill/>
-          </a:ln>
-        </p:spPr>
-        <p:txBody>
-          <a:bodyPr wrap="none" lIns="0" tIns="0" rIns="0" bIns="0" anchor="t">
-            <a:noAutofit/>
-          </a:bodyPr>
-          <a:lstStyle/>
-          <a:p>
-            <a:pPr>
-              <a:lnSpc>
-                <a:spcPts val="2928"/>
-              </a:lnSpc>
-              <a:buNone/>
-            </a:pPr>
-            <a:r>
-              <a:rPr lang="en-US" sz="2400" b="1" i="0">
-                <a:solidFill>
-                  <a:srgbClr val="EFF3F5"/>
-                </a:solidFill>
-                <a:latin typeface="Carlito"/>
-              </a:rPr>
-              <a:t xml:space="preserve">Improve existing documents</a:t>
-            </a:r>
-            <a:endParaRPr lang="en-US" sz="2400"/>
-          </a:p>
-        </p:txBody>
-      </p:sp>
-      <p:sp>
-        <p:nvSpPr>
-          <p:cNvPr id="6" name="Text 6"/>
-          <p:cNvSpPr txBox="1"/>
-          <p:nvPr/>
-        </p:nvSpPr>
-        <p:spPr>
-          <a:xfrm>
-            <a:off x="812800" y="3454400"/>
-            <a:ext cx="4965700" cy="2235200"/>
-          </a:xfrm>
-          <a:prstGeom prst="rect">
-            <a:avLst/>
-          </a:prstGeom>
-          <a:noFill/>
-          <a:ln>
-            <a:noFill/>
-          </a:ln>
-        </p:spPr>
-        <p:txBody>
-          <a:bodyPr wrap="none" lIns="0" tIns="0" rIns="0" bIns="0" anchor="t">
-            <a:noAutofit/>
-          </a:bodyPr>
-          <a:lstStyle/>
-          <a:p>
-            <a:pPr>
-              <a:lnSpc>
-                <a:spcPts val="2684"/>
-              </a:lnSpc>
-              <a:buNone/>
-            </a:pPr>
-            <a:r>
-              <a:rPr lang="en-US" sz="2200" b="0" i="0">
-                <a:solidFill>
-                  <a:srgbClr val="EFF3F5"/>
-                </a:solidFill>
-                <a:latin typeface="Carlito"/>
-              </a:rPr>
-              <a:t xml:space="preserve">Add templates and naming conventions. </a:t>
-            </a:r>
-            <a:endParaRPr lang="en-US" sz="2200"/>
-          </a:p>
-          <a:p>
-            <a:pPr>
-              <a:lnSpc>
-                <a:spcPts val="2684"/>
-              </a:lnSpc>
-              <a:buNone/>
-            </a:pPr>
-            <a:r>
-              <a:rPr lang="en-US" sz="2200" b="0" i="0">
-                <a:solidFill>
-                  <a:srgbClr val="EFF3F5"/>
-                </a:solidFill>
-                <a:latin typeface="Carlito"/>
-              </a:rPr>
-              <a:t xml:space="preserve">Faster to start, with continued manual </a:t>
-            </a:r>
-            <a:endParaRPr lang="en-US" sz="2200"/>
-          </a:p>
-          <a:p>
-            <a:pPr>
-              <a:lnSpc>
-                <a:spcPts val="2684"/>
-              </a:lnSpc>
-              <a:buNone/>
-            </a:pPr>
-            <a:r>
-              <a:rPr lang="en-US" sz="2200" b="0" i="0">
-                <a:solidFill>
-                  <a:srgbClr val="EFF3F5"/>
-                </a:solidFill>
-                <a:latin typeface="Carlito"/>
-              </a:rPr>
-              <a:t xml:space="preserve">linking.</a:t>
-            </a:r>
-            <a:endParaRPr lang="en-US" sz="2200"/>
-          </a:p>
-        </p:txBody>
-      </p:sp>
-      <p:sp>
-        <p:nvSpPr>
-          <p:cNvPr id="7" name="Shape 7"/>
-          <p:cNvSpPr/>
-          <p:nvPr/>
-        </p:nvSpPr>
-        <p:spPr>
-          <a:xfrm>
-            <a:off x="6210300" y="2336800"/>
-            <a:ext cx="5372100" cy="3556000"/>
-          </a:xfrm>
-          <a:prstGeom prst="roundRect">
-            <a:avLst/>
-          </a:prstGeom>
-          <a:solidFill>
-            <a:srgbClr val="202D3C"/>
-          </a:solidFill>
-          <a:ln>
-            <a:noFill/>
-          </a:ln>
-        </p:spPr>
-      </p:sp>
-      <p:sp>
-        <p:nvSpPr>
-          <p:cNvPr id="8" name="Text 8"/>
-          <p:cNvSpPr txBox="1"/>
-          <p:nvPr/>
-        </p:nvSpPr>
-        <p:spPr>
-          <a:xfrm>
-            <a:off x="6413500" y="2540000"/>
-            <a:ext cx="4965700" cy="812800"/>
-          </a:xfrm>
-          <a:prstGeom prst="rect">
-            <a:avLst/>
-          </a:prstGeom>
-          <a:noFill/>
-          <a:ln>
-            <a:noFill/>
-          </a:ln>
-        </p:spPr>
-        <p:txBody>
-          <a:bodyPr wrap="none" lIns="0" tIns="0" rIns="0" bIns="0" anchor="t">
-            <a:noAutofit/>
-          </a:bodyPr>
-          <a:lstStyle/>
-          <a:p>
-            <a:pPr>
-              <a:lnSpc>
-                <a:spcPts val="2928"/>
-              </a:lnSpc>
-              <a:buNone/>
-            </a:pPr>
-            <a:r>
-              <a:rPr lang="en-US" sz="2400" b="1" i="0">
-                <a:solidFill>
-                  <a:srgbClr val="EFF3F5"/>
-                </a:solidFill>
-                <a:latin typeface="Carlito"/>
-              </a:rPr>
-              <a:t xml:space="preserve">Build a focused research workspace</a:t>
-            </a:r>
-            <a:endParaRPr lang="en-US" sz="2400"/>
-          </a:p>
-        </p:txBody>
-      </p:sp>
-      <p:sp>
-        <p:nvSpPr>
-          <p:cNvPr id="9" name="Text 9"/>
-          <p:cNvSpPr txBox="1"/>
-          <p:nvPr/>
-        </p:nvSpPr>
-        <p:spPr>
-          <a:xfrm>
-            <a:off x="6413500" y="3454400"/>
-            <a:ext cx="4965700" cy="2235200"/>
-          </a:xfrm>
-          <a:prstGeom prst="rect">
-            <a:avLst/>
-          </a:prstGeom>
-          <a:noFill/>
-          <a:ln>
-            <a:noFill/>
-          </a:ln>
-        </p:spPr>
-        <p:txBody>
-          <a:bodyPr wrap="none" lIns="0" tIns="0" rIns="0" bIns="0" anchor="t">
-            <a:noAutofit/>
-          </a:bodyPr>
-          <a:lstStyle/>
-          <a:p>
-            <a:pPr>
-              <a:lnSpc>
-                <a:spcPts val="2684"/>
-              </a:lnSpc>
-              <a:buNone/>
-            </a:pPr>
-            <a:r>
-              <a:rPr lang="en-US" sz="2200" b="0" i="0">
-                <a:solidFill>
-                  <a:srgbClr val="EFF3F5"/>
-                </a:solidFill>
-                <a:latin typeface="Carlito"/>
-              </a:rPr>
-              <a:t xml:space="preserve">Link excerpts, questions and decisions </a:t>
-            </a:r>
-            <a:endParaRPr lang="en-US" sz="2200"/>
-          </a:p>
-          <a:p>
-            <a:pPr>
-              <a:lnSpc>
-                <a:spcPts val="2684"/>
-              </a:lnSpc>
-              <a:buNone/>
-            </a:pPr>
-            <a:r>
-              <a:rPr lang="en-US" sz="2200" b="0" i="0">
-                <a:solidFill>
-                  <a:srgbClr val="EFF3F5"/>
-                </a:solidFill>
-                <a:latin typeface="Carlito"/>
-              </a:rPr>
-              <a:t xml:space="preserve">locally. More initial engineering, with a </a:t>
-            </a:r>
-            <a:endParaRPr lang="en-US" sz="2200"/>
-          </a:p>
-          <a:p>
-            <a:pPr>
-              <a:lnSpc>
-                <a:spcPts val="2684"/>
-              </a:lnSpc>
-              <a:buNone/>
-            </a:pPr>
-            <a:r>
-              <a:rPr lang="en-US" sz="2200" b="0" i="0">
-                <a:solidFill>
-                  <a:srgbClr val="EFF3F5"/>
-                </a:solidFill>
-                <a:latin typeface="Carlito"/>
-              </a:rPr>
-              <a:t xml:space="preserve">narrower handoff workflow.</a:t>
-            </a:r>
-            <a:endParaRPr lang="en-US" sz="2200"/>
-          </a:p>
-        </p:txBody>
-      </p:sp>
-      <p:sp>
-        <p:nvSpPr>
-          <p:cNvPr id="10" name="Shape 10"/>
+      <p:graphicFrame>
+        <p:nvGraphicFramePr>
+          <p:cNvPr id="4" name="Chart 4"/>
+          <p:cNvGraphicFramePr/>
+          <p:nvPr/>
+        </p:nvGraphicFramePr>
+        <p:xfrm>
+          <a:off x="609600" y="2336800"/>
+          <a:ext cx="10972800" cy="3556000"/>
+        </p:xfrm>
+        <a:graphic>
+          <a:graphicData uri="http://schemas.openxmlformats.org/drawingml/2006/chart">
+            <c:chart xmlns:c="http://schemas.openxmlformats.org/drawingml/2006/chart" r:id="rId3"/>
+          </a:graphicData>
+        </a:graphic>
+      </p:graphicFrame>
+      <p:sp>
+        <p:nvSpPr>
+          <p:cNvPr id="5" name="Shape 5"/>
           <p:cNvSpPr/>
           <p:nvPr/>
         </p:nvSpPr>
@@ -2384,7 +2116,7 @@
       </p:sp>
       <p:sp>
         <p:nvSpPr>
-          <p:cNvPr id="11" name="Text 11"/>
+          <p:cNvPr id="6" name="Text 6"/>
           <p:cNvSpPr txBox="1"/>
           <p:nvPr/>
         </p:nvSpPr>
@@ -2428,7 +2160,7 @@
       </p:sp>
       <p:sp>
         <p:nvSpPr>
-          <p:cNvPr id="12" name="Text 12"/>
+          <p:cNvPr id="7" name="Text 7"/>
           <p:cNvSpPr txBox="1"/>
           <p:nvPr/>
         </p:nvSpPr>
@@ -2480,7 +2212,7 @@
 
 <file path=ppt/slides/slide5.xml><?xml version="1.0" encoding="utf-8"?>
 <p:sld xmlns:a="http://schemas.openxmlformats.org/drawingml/2006/main" xmlns:p="http://schemas.openxmlformats.org/presentationml/2006/main" xmlns:r="http://schemas.openxmlformats.org/officeDocument/2006/relationships">
-  <p:cSld name="Recommend a focused six-week pilot">
+  <p:cSld name="Two paths make the trade-off explicit">
     <p:bg>
       <p:bgPr>
         <a:solidFill>
@@ -2541,7 +2273,7 @@
                 </a:solidFill>
                 <a:latin typeface="Carlito"/>
               </a:rPr>
-              <a:t xml:space="preserve">FIELDWORK — THE RESEARCH WORKSPACE  /  RECOMMENDATION</a:t>
+              <a:t xml:space="preserve">FIELDWORK — THE RESEARCH WORKSPACE  /  OPTIONS</a:t>
             </a:r>
             <a:endParaRPr lang="en-US" sz="1100"/>
           </a:p>
@@ -2585,7 +2317,7 @@
                 </a:solidFill>
                 <a:latin typeface="Carlito"/>
               </a:rPr>
-              <a:t xml:space="preserve">Recommend a focused six-week pilot</a:t>
+              <a:t xml:space="preserve">Two paths make the trade-off explicit</a:t>
             </a:r>
             <a:endParaRPr lang="en-US" sz="4000"/>
           </a:p>
@@ -2593,14 +2325,80 @@
       </p:sp>
       <p:sp>
         <p:nvSpPr>
-          <p:cNvPr id="4" name="Text 4"/>
-          <p:cNvSpPr txBox="1"/>
+          <p:cNvPr id="4" name="Shape 4"/>
+          <p:cNvSpPr/>
           <p:nvPr/>
         </p:nvSpPr>
         <p:spPr>
           <a:xfrm>
             <a:off x="609600" y="2336800"/>
-            <a:ext cx="10972800" cy="3556000"/>
+            <a:ext cx="5372100" cy="3556000"/>
+          </a:xfrm>
+          <a:prstGeom prst="roundRect">
+            <a:avLst/>
+          </a:prstGeom>
+          <a:solidFill>
+            <a:srgbClr val="202D3C"/>
+          </a:solidFill>
+          <a:ln>
+            <a:noFill/>
+          </a:ln>
+        </p:spPr>
+      </p:sp>
+      <p:sp>
+        <p:nvSpPr>
+          <p:cNvPr id="5" name="Text 5"/>
+          <p:cNvSpPr txBox="1"/>
+          <p:nvPr/>
+        </p:nvSpPr>
+        <p:spPr>
+          <a:xfrm>
+            <a:off x="812800" y="2540000"/>
+            <a:ext cx="4965700" cy="812800"/>
+          </a:xfrm>
+          <a:prstGeom prst="rect">
+            <a:avLst/>
+          </a:prstGeom>
+          <a:noFill/>
+          <a:ln>
+            <a:noFill/>
+          </a:ln>
+        </p:spPr>
+        <p:txBody>
+          <a:bodyPr wrap="none" lIns="0" tIns="0" rIns="0" bIns="0" anchor="t">
+            <a:noAutofit/>
+          </a:bodyPr>
+          <a:lstStyle/>
+          <a:p>
+            <a:pPr>
+              <a:lnSpc>
+                <a:spcPts val="2928"/>
+              </a:lnSpc>
+              <a:buNone/>
+            </a:pPr>
+            <a:r>
+              <a:rPr lang="en-US" sz="2400" b="1" i="0">
+                <a:solidFill>
+                  <a:srgbClr val="EFF3F5"/>
+                </a:solidFill>
+                <a:latin typeface="Carlito"/>
+              </a:rPr>
+              <a:t xml:space="preserve">Improve document templates</a:t>
+            </a:r>
+            <a:endParaRPr lang="en-US" sz="2400"/>
+          </a:p>
+        </p:txBody>
+      </p:sp>
+      <p:sp>
+        <p:nvSpPr>
+          <p:cNvPr id="6" name="Text 6"/>
+          <p:cNvSpPr txBox="1"/>
+          <p:nvPr/>
+        </p:nvSpPr>
+        <p:spPr>
+          <a:xfrm>
+            <a:off x="812800" y="3454400"/>
+            <a:ext cx="4965700" cy="2235200"/>
           </a:xfrm>
           <a:prstGeom prst="rect">
             <a:avLst/>
@@ -2629,7 +2427,7 @@
                 </a:solidFill>
                 <a:latin typeface="Carlito"/>
               </a:rPr>
-              <a:t xml:space="preserve">The proposed workspace keeps source excerpts next to the decisions they inform. Pilot one </a:t>
+              <a:t xml:space="preserve">Faster to start, with the current operating </a:t>
             </a:r>
             <a:endParaRPr lang="en-US" sz="2200"/>
           </a:p>
@@ -2647,7 +2445,7 @@
                 </a:solidFill>
                 <a:latin typeface="Carlito"/>
               </a:rPr>
-              <a:t xml:space="preserve">handoff workflow before investing in integrations or automated analysis.</a:t>
+              <a:t xml:space="preserve">limitations.</a:t>
             </a:r>
             <a:endParaRPr lang="en-US" sz="2200"/>
           </a:p>
@@ -2655,7 +2453,135 @@
       </p:sp>
       <p:sp>
         <p:nvSpPr>
-          <p:cNvPr id="5" name="Shape 5"/>
+          <p:cNvPr id="7" name="Shape 7"/>
+          <p:cNvSpPr/>
+          <p:nvPr/>
+        </p:nvSpPr>
+        <p:spPr>
+          <a:xfrm>
+            <a:off x="6210300" y="2336800"/>
+            <a:ext cx="5372100" cy="3556000"/>
+          </a:xfrm>
+          <a:prstGeom prst="roundRect">
+            <a:avLst/>
+          </a:prstGeom>
+          <a:solidFill>
+            <a:srgbClr val="202D3C"/>
+          </a:solidFill>
+          <a:ln>
+            <a:noFill/>
+          </a:ln>
+        </p:spPr>
+      </p:sp>
+      <p:sp>
+        <p:nvSpPr>
+          <p:cNvPr id="8" name="Text 8"/>
+          <p:cNvSpPr txBox="1"/>
+          <p:nvPr/>
+        </p:nvSpPr>
+        <p:spPr>
+          <a:xfrm>
+            <a:off x="6413500" y="2540000"/>
+            <a:ext cx="4965700" cy="812800"/>
+          </a:xfrm>
+          <a:prstGeom prst="rect">
+            <a:avLst/>
+          </a:prstGeom>
+          <a:noFill/>
+          <a:ln>
+            <a:noFill/>
+          </a:ln>
+        </p:spPr>
+        <p:txBody>
+          <a:bodyPr wrap="none" lIns="0" tIns="0" rIns="0" bIns="0" anchor="t">
+            <a:noAutofit/>
+          </a:bodyPr>
+          <a:lstStyle/>
+          <a:p>
+            <a:pPr>
+              <a:lnSpc>
+                <a:spcPts val="2928"/>
+              </a:lnSpc>
+              <a:buNone/>
+            </a:pPr>
+            <a:r>
+              <a:rPr lang="en-US" sz="2400" b="1" i="0">
+                <a:solidFill>
+                  <a:srgbClr val="EFF3F5"/>
+                </a:solidFill>
+                <a:latin typeface="Carlito"/>
+              </a:rPr>
+              <a:t xml:space="preserve">Build a focused research workspace</a:t>
+            </a:r>
+            <a:endParaRPr lang="en-US" sz="2400"/>
+          </a:p>
+        </p:txBody>
+      </p:sp>
+      <p:sp>
+        <p:nvSpPr>
+          <p:cNvPr id="9" name="Text 9"/>
+          <p:cNvSpPr txBox="1"/>
+          <p:nvPr/>
+        </p:nvSpPr>
+        <p:spPr>
+          <a:xfrm>
+            <a:off x="6413500" y="3454400"/>
+            <a:ext cx="4965700" cy="2235200"/>
+          </a:xfrm>
+          <a:prstGeom prst="rect">
+            <a:avLst/>
+          </a:prstGeom>
+          <a:noFill/>
+          <a:ln>
+            <a:noFill/>
+          </a:ln>
+        </p:spPr>
+        <p:txBody>
+          <a:bodyPr wrap="none" lIns="0" tIns="0" rIns="0" bIns="0" anchor="t">
+            <a:noAutofit/>
+          </a:bodyPr>
+          <a:lstStyle/>
+          <a:p>
+            <a:pPr>
+              <a:lnSpc>
+                <a:spcPts val="2684"/>
+              </a:lnSpc>
+              <a:buNone/>
+            </a:pPr>
+            <a:r>
+              <a:rPr lang="en-US" sz="2200" b="0" i="0">
+                <a:solidFill>
+                  <a:srgbClr val="EFF3F5"/>
+                </a:solidFill>
+                <a:latin typeface="Carlito"/>
+              </a:rPr>
+              <a:t xml:space="preserve">More focused initial work, with a clearer </a:t>
+            </a:r>
+            <a:endParaRPr lang="en-US" sz="2200"/>
+          </a:p>
+          <a:p>
+            <a:pPr>
+              <a:lnSpc>
+                <a:spcPts val="2684"/>
+              </a:lnSpc>
+              <a:buNone/>
+            </a:pPr>
+            <a:r>
+              <a:rPr lang="en-US" sz="2200" b="0" i="0">
+                <a:solidFill>
+                  <a:srgbClr val="EFF3F5"/>
+                </a:solidFill>
+                <a:latin typeface="Carlito"/>
+              </a:rPr>
+              <a:t xml:space="preserve">review boundary.</a:t>
+            </a:r>
+            <a:endParaRPr lang="en-US" sz="2200"/>
+          </a:p>
+        </p:txBody>
+      </p:sp>
+      <p:sp>
+        <p:nvSpPr>
+          <p:cNvPr id="10" name="Shape 10"/>
           <p:cNvSpPr/>
           <p:nvPr/>
         </p:nvSpPr>
@@ -2678,7 +2604,7 @@
       </p:sp>
       <p:sp>
         <p:nvSpPr>
-          <p:cNvPr id="6" name="Text 6"/>
+          <p:cNvPr id="11" name="Text 11"/>
           <p:cNvSpPr txBox="1"/>
           <p:nvPr/>
         </p:nvSpPr>
@@ -2722,7 +2648,7 @@
       </p:sp>
       <p:sp>
         <p:nvSpPr>
-          <p:cNvPr id="7" name="Text 7"/>
+          <p:cNvPr id="12" name="Text 12"/>
           <p:cNvSpPr txBox="1"/>
           <p:nvPr/>
         </p:nvSpPr>
@@ -2774,7 +2700,7 @@
 
 <file path=ppt/slides/slide6.xml><?xml version="1.0" encoding="utf-8"?>
 <p:sld xmlns:a="http://schemas.openxmlformats.org/drawingml/2006/main" xmlns:p="http://schemas.openxmlformats.org/presentationml/2006/main" xmlns:r="http://schemas.openxmlformats.org/officeDocument/2006/relationships">
-  <p:cSld name="The main risk is adding work for researchers">
+  <p:cSld name="Recommend the bounded path">
     <p:bg>
       <p:bgPr>
         <a:solidFill>
@@ -2835,7 +2761,7 @@
                 </a:solidFill>
                 <a:latin typeface="Carlito"/>
               </a:rPr>
-              <a:t xml:space="preserve">FIELDWORK — THE RESEARCH WORKSPACE  /  IMPLICATIONS</a:t>
+              <a:t xml:space="preserve">FIELDWORK — THE RESEARCH WORKSPACE  /  RECOMMENDATION</a:t>
             </a:r>
             <a:endParaRPr lang="en-US" sz="1100"/>
           </a:p>
@@ -2879,7 +2805,7 @@
                 </a:solidFill>
                 <a:latin typeface="Carlito"/>
               </a:rPr>
-              <a:t xml:space="preserve">The main risk is adding work for researchers</a:t>
+              <a:t xml:space="preserve">Recommend the bounded path</a:t>
             </a:r>
             <a:endParaRPr lang="en-US" sz="4000"/>
           </a:p>
@@ -2923,25 +2849,7 @@
                 </a:solidFill>
                 <a:latin typeface="Carlito"/>
               </a:rPr>
-              <a:t xml:space="preserve">Keep capture lightweight. Do not make authors maintain a second copy of their notes. Review </a:t>
-            </a:r>
-            <a:endParaRPr lang="en-US" sz="2200"/>
-          </a:p>
-          <a:p>
-            <a:pPr>
-              <a:lnSpc>
-                <a:spcPts val="2684"/>
-              </a:lnSpc>
-              <a:buNone/>
-            </a:pPr>
-            <a:r>
-              <a:rPr lang="en-US" sz="2200" b="0" i="0">
-                <a:solidFill>
-                  <a:srgbClr val="EFF3F5"/>
-                </a:solidFill>
-                <a:latin typeface="Carlito"/>
-              </a:rPr>
-              <a:t xml:space="preserve">the time spent linking evidence alongside any improvement in handoff clarity.</a:t>
+              <a:t xml:space="preserve">Pilot one handoff workflow before expanding integrations.</a:t>
             </a:r>
             <a:endParaRPr lang="en-US" sz="2200"/>
           </a:p>
@@ -3068,7 +2976,7 @@
 
 <file path=ppt/slides/slide7.xml><?xml version="1.0" encoding="utf-8"?>
 <p:sld xmlns:a="http://schemas.openxmlformats.org/drawingml/2006/main" xmlns:p="http://schemas.openxmlformats.org/presentationml/2006/main" xmlns:r="http://schemas.openxmlformats.org/officeDocument/2006/relationships">
-  <p:cSld name="Next action: approve the pilot and review the evidence">
+  <p:cSld name="Keep the reasoning inspectable">
     <p:bg>
       <p:bgPr>
         <a:solidFill>
@@ -3129,7 +3037,7 @@
                 </a:solidFill>
                 <a:latin typeface="Carlito"/>
               </a:rPr>
-              <a:t xml:space="preserve">FIELDWORK — THE RESEARCH WORKSPACE  /  ACTION</a:t>
+              <a:t xml:space="preserve">FIELDWORK — THE RESEARCH WORKSPACE  /  IMPLICATIONS</a:t>
             </a:r>
             <a:endParaRPr lang="en-US" sz="1100"/>
           </a:p>
@@ -3173,51 +3081,73 @@
                 </a:solidFill>
                 <a:latin typeface="Carlito"/>
               </a:rPr>
-              <a:t xml:space="preserve">Next action: approve the pilot and review the </a:t>
+              <a:t xml:space="preserve">Keep the reasoning inspectable</a:t>
             </a:r>
             <a:endParaRPr lang="en-US" sz="4000"/>
           </a:p>
-          <a:p>
-            <a:pPr>
-              <a:lnSpc>
-                <a:spcPts val="4880"/>
-              </a:lnSpc>
-              <a:buNone/>
-            </a:pPr>
-            <a:r>
-              <a:rPr lang="en-US" sz="4000" b="1" i="0">
-                <a:solidFill>
-                  <a:srgbClr val="EFF3F5"/>
-                </a:solidFill>
-                <a:latin typeface="Carlito"/>
-              </a:rPr>
-              <a:t xml:space="preserve">evidence</a:t>
-            </a:r>
-            <a:endParaRPr lang="en-US" sz="4000"/>
-          </a:p>
-        </p:txBody>
-      </p:sp>
-      <p:sp>
-        <p:nvSpPr>
-          <p:cNvPr id="4" name="Shape 4"/>
-          <p:cNvSpPr/>
+        </p:txBody>
+      </p:sp>
+      <p:sp>
+        <p:nvSpPr>
+          <p:cNvPr id="4" name="Text 4"/>
+          <p:cNvSpPr txBox="1"/>
           <p:nvPr/>
         </p:nvSpPr>
         <p:spPr>
           <a:xfrm>
             <a:off x="609600" y="2336800"/>
-            <a:ext cx="5372100" cy="3556000"/>
-          </a:xfrm>
-          <a:prstGeom prst="roundRect">
-            <a:avLst/>
-          </a:prstGeom>
-          <a:solidFill>
-            <a:srgbClr val="202D3C"/>
-          </a:solidFill>
-          <a:ln>
-            <a:noFill/>
-          </a:ln>
-        </p:spPr>
+            <a:ext cx="10972800" cy="2946400"/>
+          </a:xfrm>
+          <a:prstGeom prst="rect">
+            <a:avLst/>
+          </a:prstGeom>
+          <a:noFill/>
+          <a:ln>
+            <a:noFill/>
+          </a:ln>
+        </p:spPr>
+        <p:txBody>
+          <a:bodyPr wrap="none" lIns="0" tIns="0" rIns="0" bIns="0" anchor="t">
+            <a:noAutofit/>
+          </a:bodyPr>
+          <a:lstStyle/>
+          <a:p>
+            <a:pPr>
+              <a:lnSpc>
+                <a:spcPts val="4148"/>
+              </a:lnSpc>
+              <a:buNone/>
+            </a:pPr>
+            <a:r>
+              <a:rPr lang="en-US" sz="3400" b="0" i="0">
+                <a:solidFill>
+                  <a:srgbClr val="EFF3F5"/>
+                </a:solidFill>
+                <a:latin typeface="Carlito"/>
+              </a:rPr>
+              <a:t xml:space="preserve">A decision should keep its supporting evidence and </a:t>
+            </a:r>
+            <a:endParaRPr lang="en-US" sz="3400"/>
+          </a:p>
+          <a:p>
+            <a:pPr>
+              <a:lnSpc>
+                <a:spcPts val="4148"/>
+              </a:lnSpc>
+              <a:buNone/>
+            </a:pPr>
+            <a:r>
+              <a:rPr lang="en-US" sz="3400" b="0" i="0">
+                <a:solidFill>
+                  <a:srgbClr val="EFF3F5"/>
+                </a:solidFill>
+                <a:latin typeface="Carlito"/>
+              </a:rPr>
+              <a:t xml:space="preserve">unresolved assumptions in view.</a:t>
+            </a:r>
+            <a:endParaRPr lang="en-US" sz="3400"/>
+          </a:p>
+        </p:txBody>
       </p:sp>
       <p:sp>
         <p:nvSpPr>
@@ -3227,52 +3157,8 @@
         </p:nvSpPr>
         <p:spPr>
           <a:xfrm>
-            <a:off x="812800" y="2540000"/>
-            <a:ext cx="4965700" cy="812800"/>
-          </a:xfrm>
-          <a:prstGeom prst="rect">
-            <a:avLst/>
-          </a:prstGeom>
-          <a:noFill/>
-          <a:ln>
-            <a:noFill/>
-          </a:ln>
-        </p:spPr>
-        <p:txBody>
-          <a:bodyPr wrap="none" lIns="0" tIns="0" rIns="0" bIns="0" anchor="t">
-            <a:noAutofit/>
-          </a:bodyPr>
-          <a:lstStyle/>
-          <a:p>
-            <a:pPr>
-              <a:lnSpc>
-                <a:spcPts val="2928"/>
-              </a:lnSpc>
-              <a:buNone/>
-            </a:pPr>
-            <a:r>
-              <a:rPr lang="en-US" sz="2400" b="1" i="0">
-                <a:solidFill>
-                  <a:srgbClr val="EFF3F5"/>
-                </a:solidFill>
-                <a:latin typeface="Carlito"/>
-              </a:rPr>
-              <a:t xml:space="preserve">Owner</a:t>
-            </a:r>
-            <a:endParaRPr lang="en-US" sz="2400"/>
-          </a:p>
-        </p:txBody>
-      </p:sp>
-      <p:sp>
-        <p:nvSpPr>
-          <p:cNvPr id="6" name="Text 6"/>
-          <p:cNvSpPr txBox="1"/>
-          <p:nvPr/>
-        </p:nvSpPr>
-        <p:spPr>
-          <a:xfrm>
-            <a:off x="812800" y="3454400"/>
-            <a:ext cx="4965700" cy="2235200"/>
+            <a:off x="609600" y="5384800"/>
+            <a:ext cx="10972800" cy="508000"/>
           </a:xfrm>
           <a:prstGeom prst="rect">
             <a:avLst/>
@@ -3297,183 +3183,19 @@
             <a:r>
               <a:rPr lang="en-US" sz="2200" b="0" i="0">
                 <a:solidFill>
-                  <a:srgbClr val="EFF3F5"/>
-                </a:solidFill>
-                <a:latin typeface="Carlito"/>
-              </a:rPr>
-              <a:t xml:space="preserve">Maya, product lead, owns recruitment and </a:t>
+                  <a:srgbClr val="A6B4C2"/>
+                </a:solidFill>
+                <a:latin typeface="Carlito"/>
+              </a:rPr>
+              <a:t xml:space="preserve">Authored synthetic principle — not a customer quotation</a:t>
             </a:r>
             <a:endParaRPr lang="en-US" sz="2200"/>
           </a:p>
-          <a:p>
-            <a:pPr>
-              <a:lnSpc>
-                <a:spcPts val="2684"/>
-              </a:lnSpc>
-              <a:buNone/>
-            </a:pPr>
-            <a:r>
-              <a:rPr lang="en-US" sz="2200" b="0" i="0">
-                <a:solidFill>
-                  <a:srgbClr val="EFF3F5"/>
-                </a:solidFill>
-                <a:latin typeface="Carlito"/>
-              </a:rPr>
-              <a:t xml:space="preserve">the pilot scope.</a:t>
-            </a:r>
-            <a:endParaRPr lang="en-US" sz="2200"/>
-          </a:p>
-        </p:txBody>
-      </p:sp>
-      <p:sp>
-        <p:nvSpPr>
-          <p:cNvPr id="7" name="Shape 7"/>
-          <p:cNvSpPr/>
-          <p:nvPr/>
-        </p:nvSpPr>
-        <p:spPr>
-          <a:xfrm>
-            <a:off x="6210300" y="2336800"/>
-            <a:ext cx="5372100" cy="3556000"/>
-          </a:xfrm>
-          <a:prstGeom prst="roundRect">
-            <a:avLst/>
-          </a:prstGeom>
-          <a:solidFill>
-            <a:srgbClr val="202D3C"/>
-          </a:solidFill>
-          <a:ln>
-            <a:noFill/>
-          </a:ln>
-        </p:spPr>
-      </p:sp>
-      <p:sp>
-        <p:nvSpPr>
-          <p:cNvPr id="8" name="Text 8"/>
-          <p:cNvSpPr txBox="1"/>
-          <p:nvPr/>
-        </p:nvSpPr>
-        <p:spPr>
-          <a:xfrm>
-            <a:off x="6413500" y="2540000"/>
-            <a:ext cx="4965700" cy="812800"/>
-          </a:xfrm>
-          <a:prstGeom prst="rect">
-            <a:avLst/>
-          </a:prstGeom>
-          <a:noFill/>
-          <a:ln>
-            <a:noFill/>
-          </a:ln>
-        </p:spPr>
-        <p:txBody>
-          <a:bodyPr wrap="none" lIns="0" tIns="0" rIns="0" bIns="0" anchor="t">
-            <a:noAutofit/>
-          </a:bodyPr>
-          <a:lstStyle/>
-          <a:p>
-            <a:pPr>
-              <a:lnSpc>
-                <a:spcPts val="2928"/>
-              </a:lnSpc>
-              <a:buNone/>
-            </a:pPr>
-            <a:r>
-              <a:rPr lang="en-US" sz="2400" b="1" i="0">
-                <a:solidFill>
-                  <a:srgbClr val="EFF3F5"/>
-                </a:solidFill>
-                <a:latin typeface="Carlito"/>
-              </a:rPr>
-              <a:t xml:space="preserve">Review point</a:t>
-            </a:r>
-            <a:endParaRPr lang="en-US" sz="2400"/>
-          </a:p>
-        </p:txBody>
-      </p:sp>
-      <p:sp>
-        <p:nvSpPr>
-          <p:cNvPr id="9" name="Text 9"/>
-          <p:cNvSpPr txBox="1"/>
-          <p:nvPr/>
-        </p:nvSpPr>
-        <p:spPr>
-          <a:xfrm>
-            <a:off x="6413500" y="3454400"/>
-            <a:ext cx="4965700" cy="2235200"/>
-          </a:xfrm>
-          <a:prstGeom prst="rect">
-            <a:avLst/>
-          </a:prstGeom>
-          <a:noFill/>
-          <a:ln>
-            <a:noFill/>
-          </a:ln>
-        </p:spPr>
-        <p:txBody>
-          <a:bodyPr wrap="none" lIns="0" tIns="0" rIns="0" bIns="0" anchor="t">
-            <a:noAutofit/>
-          </a:bodyPr>
-          <a:lstStyle/>
-          <a:p>
-            <a:pPr>
-              <a:lnSpc>
-                <a:spcPts val="2684"/>
-              </a:lnSpc>
-              <a:buNone/>
-            </a:pPr>
-            <a:r>
-              <a:rPr lang="en-US" sz="2200" b="0" i="0">
-                <a:solidFill>
-                  <a:srgbClr val="EFF3F5"/>
-                </a:solidFill>
-                <a:latin typeface="Carlito"/>
-              </a:rPr>
-              <a:t xml:space="preserve">At the end of six weeks, inspect the </a:t>
-            </a:r>
-            <a:endParaRPr lang="en-US" sz="2200"/>
-          </a:p>
-          <a:p>
-            <a:pPr>
-              <a:lnSpc>
-                <a:spcPts val="2684"/>
-              </a:lnSpc>
-              <a:buNone/>
-            </a:pPr>
-            <a:r>
-              <a:rPr lang="en-US" sz="2200" b="0" i="0">
-                <a:solidFill>
-                  <a:srgbClr val="EFF3F5"/>
-                </a:solidFill>
-                <a:latin typeface="Carlito"/>
-              </a:rPr>
-              <a:t xml:space="preserve">interview notes and decide whether to </a:t>
-            </a:r>
-            <a:endParaRPr lang="en-US" sz="2200"/>
-          </a:p>
-          <a:p>
-            <a:pPr>
-              <a:lnSpc>
-                <a:spcPts val="2684"/>
-              </a:lnSpc>
-              <a:buNone/>
-            </a:pPr>
-            <a:r>
-              <a:rPr lang="en-US" sz="2200" b="0" i="0">
-                <a:solidFill>
-                  <a:srgbClr val="EFF3F5"/>
-                </a:solidFill>
-                <a:latin typeface="Carlito"/>
-              </a:rPr>
-              <a:t xml:space="preserve">continue, revise or stop.</a:t>
-            </a:r>
-            <a:endParaRPr lang="en-US" sz="2200"/>
-          </a:p>
-        </p:txBody>
-      </p:sp>
-      <p:sp>
-        <p:nvSpPr>
-          <p:cNvPr id="10" name="Shape 10"/>
+        </p:txBody>
+      </p:sp>
+      <p:sp>
+        <p:nvSpPr>
+          <p:cNvPr id="6" name="Shape 6"/>
           <p:cNvSpPr/>
           <p:nvPr/>
         </p:nvSpPr>
@@ -3496,7 +3218,7 @@
       </p:sp>
       <p:sp>
         <p:nvSpPr>
-          <p:cNvPr id="11" name="Text 11"/>
+          <p:cNvPr id="7" name="Text 7"/>
           <p:cNvSpPr txBox="1"/>
           <p:nvPr/>
         </p:nvSpPr>
@@ -3540,7 +3262,7 @@
       </p:sp>
       <p:sp>
         <p:nvSpPr>
-          <p:cNvPr id="12" name="Text 12"/>
+          <p:cNvPr id="8" name="Text 8"/>
           <p:cNvSpPr txBox="1"/>
           <p:nvPr/>
         </p:nvSpPr>
@@ -3577,6 +3299,788 @@
                 <a:latin typeface="Carlito"/>
               </a:rPr>
               <a:t xml:space="preserve">07</a:t>
+            </a:r>
+            <a:endParaRPr lang="en-US" sz="1000"/>
+          </a:p>
+        </p:txBody>
+      </p:sp>
+    </p:spTree>
+  </p:cSld>
+  <p:clrMapOvr>
+    <a:masterClrMapping/>
+  </p:clrMapOvr>
+</p:sld>
+</file>
+
+<file path=ppt/slides/slide8.xml><?xml version="1.0" encoding="utf-8"?>
+<p:sld xmlns:a="http://schemas.openxmlformats.org/drawingml/2006/main" xmlns:p="http://schemas.openxmlformats.org/presentationml/2006/main" xmlns:r="http://schemas.openxmlformats.org/officeDocument/2006/relationships">
+  <p:cSld name="Risks to review before expansion">
+    <p:bg>
+      <p:bgPr>
+        <a:solidFill>
+          <a:srgbClr val="141C26"/>
+        </a:solidFill>
+        <a:effectLst/>
+      </p:bgPr>
+    </p:bg>
+    <p:spTree>
+      <p:nvGrpSpPr>
+        <p:cNvPr id="1" name=""/>
+        <p:cNvGrpSpPr/>
+        <p:nvPr/>
+      </p:nvGrpSpPr>
+      <p:grpSpPr>
+        <a:xfrm>
+          <a:off x="0" y="0"/>
+          <a:ext cx="0" cy="0"/>
+          <a:chOff x="0" y="0"/>
+          <a:chExt cx="0" cy="0"/>
+        </a:xfrm>
+      </p:grpSpPr>
+      <p:sp>
+        <p:nvSpPr>
+          <p:cNvPr id="2" name="Text 2"/>
+          <p:cNvSpPr txBox="1"/>
+          <p:nvPr/>
+        </p:nvSpPr>
+        <p:spPr>
+          <a:xfrm>
+            <a:off x="609600" y="304800"/>
+            <a:ext cx="10972800" cy="279400"/>
+          </a:xfrm>
+          <a:prstGeom prst="rect">
+            <a:avLst/>
+          </a:prstGeom>
+          <a:noFill/>
+          <a:ln>
+            <a:noFill/>
+          </a:ln>
+        </p:spPr>
+        <p:txBody>
+          <a:bodyPr wrap="none" lIns="0" tIns="0" rIns="0" bIns="0" anchor="t">
+            <a:noAutofit/>
+          </a:bodyPr>
+          <a:lstStyle/>
+          <a:p>
+            <a:pPr>
+              <a:lnSpc>
+                <a:spcPts val="1342"/>
+              </a:lnSpc>
+              <a:buNone/>
+            </a:pPr>
+            <a:r>
+              <a:rPr lang="en-US" sz="1100" b="0" i="0">
+                <a:solidFill>
+                  <a:srgbClr val="A6B4C2"/>
+                </a:solidFill>
+                <a:latin typeface="Carlito"/>
+              </a:rPr>
+              <a:t xml:space="preserve">FIELDWORK — THE RESEARCH WORKSPACE  /  IMPLICATIONS</a:t>
+            </a:r>
+            <a:endParaRPr lang="en-US" sz="1100"/>
+          </a:p>
+        </p:txBody>
+      </p:sp>
+      <p:sp>
+        <p:nvSpPr>
+          <p:cNvPr id="3" name="Text 3"/>
+          <p:cNvSpPr txBox="1"/>
+          <p:nvPr/>
+        </p:nvSpPr>
+        <p:spPr>
+          <a:xfrm>
+            <a:off x="609600" y="762000"/>
+            <a:ext cx="10972800" cy="1295400"/>
+          </a:xfrm>
+          <a:prstGeom prst="rect">
+            <a:avLst/>
+          </a:prstGeom>
+          <a:noFill/>
+          <a:ln>
+            <a:noFill/>
+          </a:ln>
+        </p:spPr>
+        <p:txBody>
+          <a:bodyPr wrap="none" lIns="0" tIns="0" rIns="0" bIns="0" anchor="t">
+            <a:noAutofit/>
+          </a:bodyPr>
+          <a:lstStyle/>
+          <a:p>
+            <a:pPr>
+              <a:lnSpc>
+                <a:spcPts val="4880"/>
+              </a:lnSpc>
+              <a:buNone/>
+            </a:pPr>
+            <a:r>
+              <a:rPr lang="en-US" sz="4000" b="1" i="0">
+                <a:solidFill>
+                  <a:srgbClr val="EFF3F5"/>
+                </a:solidFill>
+                <a:latin typeface="Carlito"/>
+              </a:rPr>
+              <a:t xml:space="preserve">Risks to review before expansion</a:t>
+            </a:r>
+            <a:endParaRPr lang="en-US" sz="4000"/>
+          </a:p>
+        </p:txBody>
+      </p:sp>
+      <p:sp>
+        <p:nvSpPr>
+          <p:cNvPr id="4" name="Text 4"/>
+          <p:cNvSpPr txBox="1"/>
+          <p:nvPr/>
+        </p:nvSpPr>
+        <p:spPr>
+          <a:xfrm>
+            <a:off x="609600" y="2336800"/>
+            <a:ext cx="10972800" cy="3556000"/>
+          </a:xfrm>
+          <a:prstGeom prst="rect">
+            <a:avLst/>
+          </a:prstGeom>
+          <a:noFill/>
+          <a:ln>
+            <a:noFill/>
+          </a:ln>
+        </p:spPr>
+        <p:txBody>
+          <a:bodyPr wrap="none" lIns="0" tIns="0" rIns="0" bIns="0" anchor="t">
+            <a:noAutofit/>
+          </a:bodyPr>
+          <a:lstStyle/>
+          <a:p>
+            <a:pPr>
+              <a:lnSpc>
+                <a:spcPts val="2684"/>
+              </a:lnSpc>
+              <a:buNone/>
+            </a:pPr>
+            <a:r>
+              <a:rPr lang="en-US" sz="2200" b="0" i="0">
+                <a:solidFill>
+                  <a:srgbClr val="EFF3F5"/>
+                </a:solidFill>
+                <a:latin typeface="Carlito"/>
+              </a:rPr>
+              <a:t xml:space="preserve">Keep the scope narrow. Check whether the new workflow adds manual effort or moves risk </a:t>
+            </a:r>
+            <a:endParaRPr lang="en-US" sz="2200"/>
+          </a:p>
+          <a:p>
+            <a:pPr>
+              <a:lnSpc>
+                <a:spcPts val="2684"/>
+              </a:lnSpc>
+              <a:buNone/>
+            </a:pPr>
+            <a:r>
+              <a:rPr lang="en-US" sz="2200" b="0" i="0">
+                <a:solidFill>
+                  <a:srgbClr val="EFF3F5"/>
+                </a:solidFill>
+                <a:latin typeface="Carlito"/>
+              </a:rPr>
+              <a:t xml:space="preserve">elsewhere. Record the unresolved question instead of treating an assumption as a finding.</a:t>
+            </a:r>
+            <a:endParaRPr lang="en-US" sz="2200"/>
+          </a:p>
+        </p:txBody>
+      </p:sp>
+      <p:sp>
+        <p:nvSpPr>
+          <p:cNvPr id="5" name="Shape 5"/>
+          <p:cNvSpPr/>
+          <p:nvPr/>
+        </p:nvSpPr>
+        <p:spPr>
+          <a:xfrm>
+            <a:off x="609600" y="6375400"/>
+            <a:ext cx="10972800" cy="6350"/>
+          </a:xfrm>
+          <a:prstGeom prst="line">
+            <a:avLst/>
+          </a:prstGeom>
+          <a:noFill/>
+          <a:ln w="6350">
+            <a:solidFill>
+              <a:srgbClr val="A6B4C2"/>
+            </a:solidFill>
+            <a:prstDash val="solid"/>
+          </a:ln>
+        </p:spPr>
+      </p:sp>
+      <p:sp>
+        <p:nvSpPr>
+          <p:cNvPr id="6" name="Text 6"/>
+          <p:cNvSpPr txBox="1"/>
+          <p:nvPr/>
+        </p:nvSpPr>
+        <p:spPr>
+          <a:xfrm>
+            <a:off x="609600" y="6502400"/>
+            <a:ext cx="10210800" cy="254000"/>
+          </a:xfrm>
+          <a:prstGeom prst="rect">
+            <a:avLst/>
+          </a:prstGeom>
+          <a:noFill/>
+          <a:ln>
+            <a:noFill/>
+          </a:ln>
+        </p:spPr>
+        <p:txBody>
+          <a:bodyPr wrap="none" lIns="0" tIns="0" rIns="0" bIns="0" anchor="t">
+            <a:noAutofit/>
+          </a:bodyPr>
+          <a:lstStyle/>
+          <a:p>
+            <a:pPr>
+              <a:lnSpc>
+                <a:spcPts val="1220"/>
+              </a:lnSpc>
+              <a:buNone/>
+            </a:pPr>
+            <a:r>
+              <a:rPr lang="en-US" sz="1000" b="0" i="0">
+                <a:solidFill>
+                  <a:srgbClr val="A6B4C2"/>
+                </a:solidFill>
+                <a:latin typeface="Carlito"/>
+              </a:rPr>
+              <a:t xml:space="preserve">SYNTHETIC EXAMPLE  ·  STORYBOARD STUDIO</a:t>
+            </a:r>
+            <a:endParaRPr lang="en-US" sz="1000"/>
+          </a:p>
+        </p:txBody>
+      </p:sp>
+      <p:sp>
+        <p:nvSpPr>
+          <p:cNvPr id="7" name="Text 7"/>
+          <p:cNvSpPr txBox="1"/>
+          <p:nvPr/>
+        </p:nvSpPr>
+        <p:spPr>
+          <a:xfrm>
+            <a:off x="11010900" y="6502400"/>
+            <a:ext cx="571500" cy="254000"/>
+          </a:xfrm>
+          <a:prstGeom prst="rect">
+            <a:avLst/>
+          </a:prstGeom>
+          <a:noFill/>
+          <a:ln>
+            <a:noFill/>
+          </a:ln>
+        </p:spPr>
+        <p:txBody>
+          <a:bodyPr wrap="none" lIns="0" tIns="0" rIns="0" bIns="0" anchor="t">
+            <a:noAutofit/>
+          </a:bodyPr>
+          <a:lstStyle/>
+          <a:p>
+            <a:pPr>
+              <a:lnSpc>
+                <a:spcPts val="1220"/>
+              </a:lnSpc>
+              <a:buNone/>
+            </a:pPr>
+            <a:r>
+              <a:rPr lang="en-US" sz="1000" b="0" i="0">
+                <a:solidFill>
+                  <a:srgbClr val="A6B4C2"/>
+                </a:solidFill>
+                <a:latin typeface="Carlito"/>
+              </a:rPr>
+              <a:t xml:space="preserve">08</a:t>
+            </a:r>
+            <a:endParaRPr lang="en-US" sz="1000"/>
+          </a:p>
+        </p:txBody>
+      </p:sp>
+    </p:spTree>
+  </p:cSld>
+  <p:clrMapOvr>
+    <a:masterClrMapping/>
+  </p:clrMapOvr>
+</p:sld>
+</file>
+
+<file path=ppt/slides/slide9.xml><?xml version="1.0" encoding="utf-8"?>
+<p:sld xmlns:a="http://schemas.openxmlformats.org/drawingml/2006/main" xmlns:p="http://schemas.openxmlformats.org/presentationml/2006/main" xmlns:r="http://schemas.openxmlformats.org/officeDocument/2006/relationships">
+  <p:cSld name="Next action: approve the pilot and own the review">
+    <p:bg>
+      <p:bgPr>
+        <a:solidFill>
+          <a:srgbClr val="141C26"/>
+        </a:solidFill>
+        <a:effectLst/>
+      </p:bgPr>
+    </p:bg>
+    <p:spTree>
+      <p:nvGrpSpPr>
+        <p:cNvPr id="1" name=""/>
+        <p:cNvGrpSpPr/>
+        <p:nvPr/>
+      </p:nvGrpSpPr>
+      <p:grpSpPr>
+        <a:xfrm>
+          <a:off x="0" y="0"/>
+          <a:ext cx="0" cy="0"/>
+          <a:chOff x="0" y="0"/>
+          <a:chExt cx="0" cy="0"/>
+        </a:xfrm>
+      </p:grpSpPr>
+      <p:sp>
+        <p:nvSpPr>
+          <p:cNvPr id="2" name="Text 2"/>
+          <p:cNvSpPr txBox="1"/>
+          <p:nvPr/>
+        </p:nvSpPr>
+        <p:spPr>
+          <a:xfrm>
+            <a:off x="609600" y="304800"/>
+            <a:ext cx="10972800" cy="279400"/>
+          </a:xfrm>
+          <a:prstGeom prst="rect">
+            <a:avLst/>
+          </a:prstGeom>
+          <a:noFill/>
+          <a:ln>
+            <a:noFill/>
+          </a:ln>
+        </p:spPr>
+        <p:txBody>
+          <a:bodyPr wrap="none" lIns="0" tIns="0" rIns="0" bIns="0" anchor="t">
+            <a:noAutofit/>
+          </a:bodyPr>
+          <a:lstStyle/>
+          <a:p>
+            <a:pPr>
+              <a:lnSpc>
+                <a:spcPts val="1342"/>
+              </a:lnSpc>
+              <a:buNone/>
+            </a:pPr>
+            <a:r>
+              <a:rPr lang="en-US" sz="1100" b="0" i="0">
+                <a:solidFill>
+                  <a:srgbClr val="A6B4C2"/>
+                </a:solidFill>
+                <a:latin typeface="Carlito"/>
+              </a:rPr>
+              <a:t xml:space="preserve">FIELDWORK — THE RESEARCH WORKSPACE  /  ACTION</a:t>
+            </a:r>
+            <a:endParaRPr lang="en-US" sz="1100"/>
+          </a:p>
+        </p:txBody>
+      </p:sp>
+      <p:sp>
+        <p:nvSpPr>
+          <p:cNvPr id="3" name="Text 3"/>
+          <p:cNvSpPr txBox="1"/>
+          <p:nvPr/>
+        </p:nvSpPr>
+        <p:spPr>
+          <a:xfrm>
+            <a:off x="609600" y="762000"/>
+            <a:ext cx="10972800" cy="1295400"/>
+          </a:xfrm>
+          <a:prstGeom prst="rect">
+            <a:avLst/>
+          </a:prstGeom>
+          <a:noFill/>
+          <a:ln>
+            <a:noFill/>
+          </a:ln>
+        </p:spPr>
+        <p:txBody>
+          <a:bodyPr wrap="none" lIns="0" tIns="0" rIns="0" bIns="0" anchor="t">
+            <a:noAutofit/>
+          </a:bodyPr>
+          <a:lstStyle/>
+          <a:p>
+            <a:pPr>
+              <a:lnSpc>
+                <a:spcPts val="4880"/>
+              </a:lnSpc>
+              <a:buNone/>
+            </a:pPr>
+            <a:r>
+              <a:rPr lang="en-US" sz="4000" b="1" i="0">
+                <a:solidFill>
+                  <a:srgbClr val="EFF3F5"/>
+                </a:solidFill>
+                <a:latin typeface="Carlito"/>
+              </a:rPr>
+              <a:t xml:space="preserve">Next action: approve the pilot and own the review</a:t>
+            </a:r>
+            <a:endParaRPr lang="en-US" sz="4000"/>
+          </a:p>
+        </p:txBody>
+      </p:sp>
+      <p:sp>
+        <p:nvSpPr>
+          <p:cNvPr id="4" name="Shape 4"/>
+          <p:cNvSpPr/>
+          <p:nvPr/>
+        </p:nvSpPr>
+        <p:spPr>
+          <a:xfrm>
+            <a:off x="609600" y="2336800"/>
+            <a:ext cx="5372100" cy="3556000"/>
+          </a:xfrm>
+          <a:prstGeom prst="roundRect">
+            <a:avLst/>
+          </a:prstGeom>
+          <a:solidFill>
+            <a:srgbClr val="202D3C"/>
+          </a:solidFill>
+          <a:ln>
+            <a:noFill/>
+          </a:ln>
+        </p:spPr>
+      </p:sp>
+      <p:sp>
+        <p:nvSpPr>
+          <p:cNvPr id="5" name="Text 5"/>
+          <p:cNvSpPr txBox="1"/>
+          <p:nvPr/>
+        </p:nvSpPr>
+        <p:spPr>
+          <a:xfrm>
+            <a:off x="812800" y="2540000"/>
+            <a:ext cx="4965700" cy="812800"/>
+          </a:xfrm>
+          <a:prstGeom prst="rect">
+            <a:avLst/>
+          </a:prstGeom>
+          <a:noFill/>
+          <a:ln>
+            <a:noFill/>
+          </a:ln>
+        </p:spPr>
+        <p:txBody>
+          <a:bodyPr wrap="none" lIns="0" tIns="0" rIns="0" bIns="0" anchor="t">
+            <a:noAutofit/>
+          </a:bodyPr>
+          <a:lstStyle/>
+          <a:p>
+            <a:pPr>
+              <a:lnSpc>
+                <a:spcPts val="2928"/>
+              </a:lnSpc>
+              <a:buNone/>
+            </a:pPr>
+            <a:r>
+              <a:rPr lang="en-US" sz="2400" b="1" i="0">
+                <a:solidFill>
+                  <a:srgbClr val="EFF3F5"/>
+                </a:solidFill>
+                <a:latin typeface="Carlito"/>
+              </a:rPr>
+              <a:t xml:space="preserve">Owner</a:t>
+            </a:r>
+            <a:endParaRPr lang="en-US" sz="2400"/>
+          </a:p>
+        </p:txBody>
+      </p:sp>
+      <p:sp>
+        <p:nvSpPr>
+          <p:cNvPr id="6" name="Text 6"/>
+          <p:cNvSpPr txBox="1"/>
+          <p:nvPr/>
+        </p:nvSpPr>
+        <p:spPr>
+          <a:xfrm>
+            <a:off x="812800" y="3454400"/>
+            <a:ext cx="4965700" cy="2235200"/>
+          </a:xfrm>
+          <a:prstGeom prst="rect">
+            <a:avLst/>
+          </a:prstGeom>
+          <a:noFill/>
+          <a:ln>
+            <a:noFill/>
+          </a:ln>
+        </p:spPr>
+        <p:txBody>
+          <a:bodyPr wrap="none" lIns="0" tIns="0" rIns="0" bIns="0" anchor="t">
+            <a:noAutofit/>
+          </a:bodyPr>
+          <a:lstStyle/>
+          <a:p>
+            <a:pPr>
+              <a:lnSpc>
+                <a:spcPts val="2684"/>
+              </a:lnSpc>
+              <a:buNone/>
+            </a:pPr>
+            <a:r>
+              <a:rPr lang="en-US" sz="2200" b="0" i="0">
+                <a:solidFill>
+                  <a:srgbClr val="EFF3F5"/>
+                </a:solidFill>
+                <a:latin typeface="Carlito"/>
+              </a:rPr>
+              <a:t xml:space="preserve">Research lead owns the first milestone and </a:t>
+            </a:r>
+            <a:endParaRPr lang="en-US" sz="2200"/>
+          </a:p>
+          <a:p>
+            <a:pPr>
+              <a:lnSpc>
+                <a:spcPts val="2684"/>
+              </a:lnSpc>
+              <a:buNone/>
+            </a:pPr>
+            <a:r>
+              <a:rPr lang="en-US" sz="2200" b="0" i="0">
+                <a:solidFill>
+                  <a:srgbClr val="EFF3F5"/>
+                </a:solidFill>
+                <a:latin typeface="Carlito"/>
+              </a:rPr>
+              <a:t xml:space="preserve">its evidence.</a:t>
+            </a:r>
+            <a:endParaRPr lang="en-US" sz="2200"/>
+          </a:p>
+        </p:txBody>
+      </p:sp>
+      <p:sp>
+        <p:nvSpPr>
+          <p:cNvPr id="7" name="Shape 7"/>
+          <p:cNvSpPr/>
+          <p:nvPr/>
+        </p:nvSpPr>
+        <p:spPr>
+          <a:xfrm>
+            <a:off x="6210300" y="2336800"/>
+            <a:ext cx="5372100" cy="3556000"/>
+          </a:xfrm>
+          <a:prstGeom prst="roundRect">
+            <a:avLst/>
+          </a:prstGeom>
+          <a:solidFill>
+            <a:srgbClr val="202D3C"/>
+          </a:solidFill>
+          <a:ln>
+            <a:noFill/>
+          </a:ln>
+        </p:spPr>
+      </p:sp>
+      <p:sp>
+        <p:nvSpPr>
+          <p:cNvPr id="8" name="Text 8"/>
+          <p:cNvSpPr txBox="1"/>
+          <p:nvPr/>
+        </p:nvSpPr>
+        <p:spPr>
+          <a:xfrm>
+            <a:off x="6413500" y="2540000"/>
+            <a:ext cx="4965700" cy="812800"/>
+          </a:xfrm>
+          <a:prstGeom prst="rect">
+            <a:avLst/>
+          </a:prstGeom>
+          <a:noFill/>
+          <a:ln>
+            <a:noFill/>
+          </a:ln>
+        </p:spPr>
+        <p:txBody>
+          <a:bodyPr wrap="none" lIns="0" tIns="0" rIns="0" bIns="0" anchor="t">
+            <a:noAutofit/>
+          </a:bodyPr>
+          <a:lstStyle/>
+          <a:p>
+            <a:pPr>
+              <a:lnSpc>
+                <a:spcPts val="2928"/>
+              </a:lnSpc>
+              <a:buNone/>
+            </a:pPr>
+            <a:r>
+              <a:rPr lang="en-US" sz="2400" b="1" i="0">
+                <a:solidFill>
+                  <a:srgbClr val="EFF3F5"/>
+                </a:solidFill>
+                <a:latin typeface="Carlito"/>
+              </a:rPr>
+              <a:t xml:space="preserve">Review</a:t>
+            </a:r>
+            <a:endParaRPr lang="en-US" sz="2400"/>
+          </a:p>
+        </p:txBody>
+      </p:sp>
+      <p:sp>
+        <p:nvSpPr>
+          <p:cNvPr id="9" name="Text 9"/>
+          <p:cNvSpPr txBox="1"/>
+          <p:nvPr/>
+        </p:nvSpPr>
+        <p:spPr>
+          <a:xfrm>
+            <a:off x="6413500" y="3454400"/>
+            <a:ext cx="4965700" cy="2235200"/>
+          </a:xfrm>
+          <a:prstGeom prst="rect">
+            <a:avLst/>
+          </a:prstGeom>
+          <a:noFill/>
+          <a:ln>
+            <a:noFill/>
+          </a:ln>
+        </p:spPr>
+        <p:txBody>
+          <a:bodyPr wrap="none" lIns="0" tIns="0" rIns="0" bIns="0" anchor="t">
+            <a:noAutofit/>
+          </a:bodyPr>
+          <a:lstStyle/>
+          <a:p>
+            <a:pPr>
+              <a:lnSpc>
+                <a:spcPts val="2684"/>
+              </a:lnSpc>
+              <a:buNone/>
+            </a:pPr>
+            <a:r>
+              <a:rPr lang="en-US" sz="2200" b="0" i="0">
+                <a:solidFill>
+                  <a:srgbClr val="EFF3F5"/>
+                </a:solidFill>
+                <a:latin typeface="Carlito"/>
+              </a:rPr>
+              <a:t xml:space="preserve">Inspect the pilot evidence before </a:t>
+            </a:r>
+            <a:endParaRPr lang="en-US" sz="2200"/>
+          </a:p>
+          <a:p>
+            <a:pPr>
+              <a:lnSpc>
+                <a:spcPts val="2684"/>
+              </a:lnSpc>
+              <a:buNone/>
+            </a:pPr>
+            <a:r>
+              <a:rPr lang="en-US" sz="2200" b="0" i="0">
+                <a:solidFill>
+                  <a:srgbClr val="EFF3F5"/>
+                </a:solidFill>
+                <a:latin typeface="Carlito"/>
+              </a:rPr>
+              <a:t xml:space="preserve">approving the next stage.</a:t>
+            </a:r>
+            <a:endParaRPr lang="en-US" sz="2200"/>
+          </a:p>
+        </p:txBody>
+      </p:sp>
+      <p:sp>
+        <p:nvSpPr>
+          <p:cNvPr id="10" name="Shape 10"/>
+          <p:cNvSpPr/>
+          <p:nvPr/>
+        </p:nvSpPr>
+        <p:spPr>
+          <a:xfrm>
+            <a:off x="609600" y="6375400"/>
+            <a:ext cx="10972800" cy="6350"/>
+          </a:xfrm>
+          <a:prstGeom prst="line">
+            <a:avLst/>
+          </a:prstGeom>
+          <a:noFill/>
+          <a:ln w="6350">
+            <a:solidFill>
+              <a:srgbClr val="A6B4C2"/>
+            </a:solidFill>
+            <a:prstDash val="solid"/>
+          </a:ln>
+        </p:spPr>
+      </p:sp>
+      <p:sp>
+        <p:nvSpPr>
+          <p:cNvPr id="11" name="Text 11"/>
+          <p:cNvSpPr txBox="1"/>
+          <p:nvPr/>
+        </p:nvSpPr>
+        <p:spPr>
+          <a:xfrm>
+            <a:off x="609600" y="6502400"/>
+            <a:ext cx="10210800" cy="254000"/>
+          </a:xfrm>
+          <a:prstGeom prst="rect">
+            <a:avLst/>
+          </a:prstGeom>
+          <a:noFill/>
+          <a:ln>
+            <a:noFill/>
+          </a:ln>
+        </p:spPr>
+        <p:txBody>
+          <a:bodyPr wrap="none" lIns="0" tIns="0" rIns="0" bIns="0" anchor="t">
+            <a:noAutofit/>
+          </a:bodyPr>
+          <a:lstStyle/>
+          <a:p>
+            <a:pPr>
+              <a:lnSpc>
+                <a:spcPts val="1220"/>
+              </a:lnSpc>
+              <a:buNone/>
+            </a:pPr>
+            <a:r>
+              <a:rPr lang="en-US" sz="1000" b="0" i="0">
+                <a:solidFill>
+                  <a:srgbClr val="A6B4C2"/>
+                </a:solidFill>
+                <a:latin typeface="Carlito"/>
+              </a:rPr>
+              <a:t xml:space="preserve">SYNTHETIC EXAMPLE  ·  STORYBOARD STUDIO</a:t>
+            </a:r>
+            <a:endParaRPr lang="en-US" sz="1000"/>
+          </a:p>
+        </p:txBody>
+      </p:sp>
+      <p:sp>
+        <p:nvSpPr>
+          <p:cNvPr id="12" name="Text 12"/>
+          <p:cNvSpPr txBox="1"/>
+          <p:nvPr/>
+        </p:nvSpPr>
+        <p:spPr>
+          <a:xfrm>
+            <a:off x="11010900" y="6502400"/>
+            <a:ext cx="571500" cy="254000"/>
+          </a:xfrm>
+          <a:prstGeom prst="rect">
+            <a:avLst/>
+          </a:prstGeom>
+          <a:noFill/>
+          <a:ln>
+            <a:noFill/>
+          </a:ln>
+        </p:spPr>
+        <p:txBody>
+          <a:bodyPr wrap="none" lIns="0" tIns="0" rIns="0" bIns="0" anchor="t">
+            <a:noAutofit/>
+          </a:bodyPr>
+          <a:lstStyle/>
+          <a:p>
+            <a:pPr>
+              <a:lnSpc>
+                <a:spcPts val="1220"/>
+              </a:lnSpc>
+              <a:buNone/>
+            </a:pPr>
+            <a:r>
+              <a:rPr lang="en-US" sz="1000" b="0" i="0">
+                <a:solidFill>
+                  <a:srgbClr val="A6B4C2"/>
+                </a:solidFill>
+                <a:latin typeface="Carlito"/>
+              </a:rPr>
+              <a:t xml:space="preserve">09</a:t>
             </a:r>
             <a:endParaRPr lang="en-US" sz="1000"/>
           </a:p>

</xml_diff>